<commit_message>
feat(shapes): enhance auto-sizing with font-aware metrics and improved text wrapping
- Add FontMetrics struct with char_width_ratio, line_height_ratio, and monospace detection
- Implement font-specific metrics for Consolas, Arial, Calibri, Times New Roman, and fallback
- Rewrite calculate_font_size() with EMU-to-points conversion and configurable padding
- Add calculate_font_size_with_font() for font-family-aware sizing
- Implement estimate_wrapped_lines() heuristic for proportional fonts
- Expand
</commit_message>
<xml_diff>
--- a/comprehensive_demo.pptx
+++ b/comprehensive_demo.pptx
@@ -463,14 +463,14 @@
           </a:gradFill>
         </p:spPr>
         <p:txBody>
-          <a:bodyPr wrap="square" rtlCol="0" anchor="ctr">
-            <a:normAutofit/>
+          <a:bodyPr wrap="square" rtlCol="0" anchor="ctr" lIns="91440" tIns="45720" rIns="91440" bIns="45720">
+            <a:normAutofit fontScale="100000" lnSpcReduction="0"/>
           </a:bodyPr>
           <a:lstStyle/>
           <a:p>
-            <a:pPr algn="ctr"/>
-            <a:r>
-              <a:rPr lang="en-US" sz="3937" dirty="0">
+            <a:pPr algn="ctr" marL="0" marR="0" indent="0"/>
+            <a:r>
+              <a:rPr lang="en-US" sz="3649" dirty="0" smtClean="0">
                 <a:solidFill>
                   <a:srgbClr val="000000"/>
                 </a:solidFill>
@@ -507,14 +507,14 @@
           </a:gradFill>
         </p:spPr>
         <p:txBody>
-          <a:bodyPr wrap="square" rtlCol="0" anchor="ctr">
-            <a:normAutofit/>
+          <a:bodyPr wrap="square" rtlCol="0" anchor="ctr" lIns="91440" tIns="45720" rIns="91440" bIns="45720">
+            <a:normAutofit fontScale="100000" lnSpcReduction="0"/>
           </a:bodyPr>
           <a:lstStyle/>
           <a:p>
-            <a:pPr algn="ctr"/>
-            <a:r>
-              <a:rPr lang="en-US" sz="4400" dirty="0">
+            <a:pPr algn="ctr" marL="0" marR="0" indent="0"/>
+            <a:r>
+              <a:rPr lang="en-US" sz="4561" dirty="0" smtClean="0">
                 <a:solidFill>
                   <a:srgbClr val="000000"/>
                 </a:solidFill>
@@ -551,14 +551,14 @@
           </a:gradFill>
         </p:spPr>
         <p:txBody>
-          <a:bodyPr wrap="square" rtlCol="0" anchor="ctr">
-            <a:normAutofit/>
+          <a:bodyPr wrap="square" rtlCol="0" anchor="ctr" lIns="91440" tIns="45720" rIns="91440" bIns="45720">
+            <a:normAutofit fontScale="100000" lnSpcReduction="0"/>
           </a:bodyPr>
           <a:lstStyle/>
           <a:p>
-            <a:pPr algn="ctr"/>
-            <a:r>
-              <a:rPr lang="en-US" sz="4400" dirty="0">
+            <a:pPr algn="ctr" marL="0" marR="0" indent="0"/>
+            <a:r>
+              <a:rPr lang="en-US" sz="4561" dirty="0" smtClean="0">
                 <a:solidFill>
                   <a:srgbClr val="000000"/>
                 </a:solidFill>
@@ -598,14 +598,14 @@
           </a:gradFill>
         </p:spPr>
         <p:txBody>
-          <a:bodyPr wrap="square" rtlCol="0" anchor="ctr">
-            <a:normAutofit/>
+          <a:bodyPr wrap="square" rtlCol="0" anchor="ctr" lIns="91440" tIns="45720" rIns="91440" bIns="45720">
+            <a:normAutofit fontScale="100000" lnSpcReduction="0"/>
           </a:bodyPr>
           <a:lstStyle/>
           <a:p>
-            <a:pPr algn="ctr"/>
-            <a:r>
-              <a:rPr lang="en-US" sz="4400" dirty="0">
+            <a:pPr algn="ctr" marL="0" marR="0" indent="0"/>
+            <a:r>
+              <a:rPr lang="en-US" sz="5212" dirty="0" smtClean="0">
                 <a:solidFill>
                   <a:srgbClr val="000000"/>
                 </a:solidFill>
@@ -642,14 +642,14 @@
           </a:gradFill>
         </p:spPr>
         <p:txBody>
-          <a:bodyPr wrap="square" rtlCol="0" anchor="ctr">
-            <a:normAutofit/>
+          <a:bodyPr wrap="square" rtlCol="0" anchor="ctr" lIns="91440" tIns="45720" rIns="91440" bIns="45720">
+            <a:normAutofit fontScale="100000" lnSpcReduction="0"/>
           </a:bodyPr>
           <a:lstStyle/>
           <a:p>
-            <a:pPr algn="ctr"/>
-            <a:r>
-              <a:rPr lang="en-US" sz="3937" dirty="0">
+            <a:pPr algn="ctr" marL="0" marR="0" indent="0"/>
+            <a:r>
+              <a:rPr lang="en-US" sz="3649" dirty="0" smtClean="0">
                 <a:solidFill>
                   <a:srgbClr val="000000"/>
                 </a:solidFill>
@@ -740,14 +740,14 @@
           </a:solidFill>
         </p:spPr>
         <p:txBody>
-          <a:bodyPr wrap="square" rtlCol="0" anchor="ctr">
-            <a:normAutofit/>
+          <a:bodyPr wrap="square" rtlCol="0" anchor="ctr" lIns="91440" tIns="45720" rIns="91440" bIns="45720">
+            <a:normAutofit fontScale="100000" lnSpcReduction="0"/>
           </a:bodyPr>
           <a:lstStyle/>
           <a:p>
-            <a:pPr algn="ctr"/>
-            <a:r>
-              <a:rPr lang="en-US" sz="4294" dirty="0">
+            <a:pPr algn="ctr" marL="0" marR="0" indent="0"/>
+            <a:r>
+              <a:rPr lang="en-US" sz="4033" dirty="0" smtClean="0">
                 <a:solidFill>
                   <a:srgbClr val="FFFFFF"/>
                 </a:solidFill>
@@ -783,14 +783,14 @@
           </a:ln>
         </p:spPr>
         <p:txBody>
-          <a:bodyPr wrap="square" rtlCol="0" anchor="ctr">
-            <a:normAutofit/>
+          <a:bodyPr wrap="square" rtlCol="0" anchor="ctr" lIns="91440" tIns="45720" rIns="91440" bIns="45720">
+            <a:normAutofit fontScale="100000" lnSpcReduction="0"/>
           </a:bodyPr>
           <a:lstStyle/>
           <a:p>
-            <a:pPr algn="ctr"/>
-            <a:r>
-              <a:rPr lang="en-US" sz="2624" dirty="0">
+            <a:pPr algn="ctr" marL="0" marR="0" indent="0"/>
+            <a:r>
+              <a:rPr lang="en-US" sz="2432" dirty="0" smtClean="0">
                 <a:solidFill>
                   <a:srgbClr val="FFFFFF"/>
                 </a:solidFill>
@@ -826,14 +826,14 @@
           </a:ln>
         </p:spPr>
         <p:txBody>
-          <a:bodyPr wrap="square" rtlCol="0" anchor="ctr">
-            <a:normAutofit/>
+          <a:bodyPr wrap="square" rtlCol="0" anchor="ctr" lIns="91440" tIns="45720" rIns="91440" bIns="45720">
+            <a:normAutofit fontScale="100000" lnSpcReduction="0"/>
           </a:bodyPr>
           <a:lstStyle/>
           <a:p>
-            <a:pPr algn="ctr"/>
-            <a:r>
-              <a:rPr lang="en-US" sz="2624" dirty="0">
+            <a:pPr algn="ctr" marL="0" marR="0" indent="0"/>
+            <a:r>
+              <a:rPr lang="en-US" sz="2432" dirty="0" smtClean="0">
                 <a:solidFill>
                   <a:srgbClr val="000000"/>
                 </a:solidFill>
@@ -869,14 +869,14 @@
           </a:ln>
         </p:spPr>
         <p:txBody>
-          <a:bodyPr wrap="square" rtlCol="0" anchor="ctr">
-            <a:normAutofit/>
+          <a:bodyPr wrap="square" rtlCol="0" anchor="ctr" lIns="91440" tIns="45720" rIns="91440" bIns="45720">
+            <a:normAutofit fontScale="100000" lnSpcReduction="0"/>
           </a:bodyPr>
           <a:lstStyle/>
           <a:p>
-            <a:pPr algn="ctr"/>
-            <a:r>
-              <a:rPr lang="en-US" sz="2624" dirty="0">
+            <a:pPr algn="ctr" marL="0" marR="0" indent="0"/>
+            <a:r>
+              <a:rPr lang="en-US" sz="2432" dirty="0" smtClean="0">
                 <a:solidFill>
                   <a:srgbClr val="000000"/>
                 </a:solidFill>
@@ -967,14 +967,14 @@
           </a:solidFill>
         </p:spPr>
         <p:txBody>
-          <a:bodyPr wrap="square" rtlCol="0" anchor="ctr">
-            <a:normAutofit/>
+          <a:bodyPr wrap="square" rtlCol="0" anchor="ctr" lIns="91440" tIns="45720" rIns="91440" bIns="45720">
+            <a:normAutofit fontScale="100000" lnSpcReduction="0"/>
           </a:bodyPr>
           <a:lstStyle/>
           <a:p>
-            <a:pPr algn="ctr"/>
-            <a:r>
-              <a:rPr lang="en-US" sz="4400" dirty="0">
+            <a:pPr algn="ctr" marL="0" marR="0" indent="0"/>
+            <a:r>
+              <a:rPr lang="en-US" sz="4225" dirty="0" smtClean="0">
                 <a:solidFill>
                   <a:srgbClr val="FFFFFF"/>
                 </a:solidFill>
@@ -1003,14 +1003,14 @@
           </a:solidFill>
         </p:spPr>
         <p:txBody>
-          <a:bodyPr wrap="square" rtlCol="0" anchor="ctr">
-            <a:normAutofit/>
+          <a:bodyPr wrap="square" rtlCol="0" anchor="ctr" lIns="91440" tIns="45720" rIns="91440" bIns="45720">
+            <a:normAutofit fontScale="100000" lnSpcReduction="0"/>
           </a:bodyPr>
           <a:lstStyle/>
           <a:p>
-            <a:pPr algn="ctr"/>
-            <a:r>
-              <a:rPr lang="en-US" sz="4049" dirty="0">
+            <a:pPr algn="ctr" marL="0" marR="0" indent="0"/>
+            <a:r>
+              <a:rPr lang="en-US" sz="3638" dirty="0" smtClean="0">
                 <a:solidFill>
                   <a:srgbClr val="FFFFFF"/>
                 </a:solidFill>
@@ -1039,14 +1039,14 @@
           </a:solidFill>
         </p:spPr>
         <p:txBody>
-          <a:bodyPr wrap="square" rtlCol="0" anchor="ctr">
-            <a:normAutofit/>
+          <a:bodyPr wrap="square" rtlCol="0" anchor="ctr" lIns="91440" tIns="45720" rIns="91440" bIns="45720">
+            <a:normAutofit fontScale="100000" lnSpcReduction="0"/>
           </a:bodyPr>
           <a:lstStyle/>
           <a:p>
-            <a:pPr algn="ctr"/>
-            <a:r>
-              <a:rPr lang="en-US" sz="4400" dirty="0">
+            <a:pPr algn="ctr" marL="0" marR="0" indent="0"/>
+            <a:r>
+              <a:rPr lang="en-US" sz="4225" dirty="0" smtClean="0">
                 <a:solidFill>
                   <a:srgbClr val="FFFFFF"/>
                 </a:solidFill>
@@ -1075,14 +1075,14 @@
           </a:solidFill>
         </p:spPr>
         <p:txBody>
-          <a:bodyPr wrap="square" rtlCol="0" anchor="ctr">
-            <a:normAutofit/>
+          <a:bodyPr wrap="square" rtlCol="0" anchor="ctr" lIns="91440" tIns="45720" rIns="91440" bIns="45720">
+            <a:normAutofit fontScale="100000" lnSpcReduction="0"/>
           </a:bodyPr>
           <a:lstStyle/>
           <a:p>
-            <a:pPr algn="ctr"/>
-            <a:r>
-              <a:rPr lang="en-US" sz="4400" dirty="0">
+            <a:pPr algn="ctr" marL="0" marR="0" indent="0"/>
+            <a:r>
+              <a:rPr lang="en-US" sz="4225" dirty="0" smtClean="0">
                 <a:solidFill>
                   <a:srgbClr val="FFFFFF"/>
                 </a:solidFill>
@@ -1111,14 +1111,14 @@
           </a:solidFill>
         </p:spPr>
         <p:txBody>
-          <a:bodyPr wrap="square" rtlCol="0" anchor="ctr">
-            <a:normAutofit/>
+          <a:bodyPr wrap="square" rtlCol="0" anchor="ctr" lIns="91440" tIns="45720" rIns="91440" bIns="45720">
+            <a:normAutofit fontScale="100000" lnSpcReduction="0"/>
           </a:bodyPr>
           <a:lstStyle/>
           <a:p>
-            <a:pPr algn="ctr"/>
-            <a:r>
-              <a:rPr lang="en-US" sz="4400" dirty="0">
+            <a:pPr algn="ctr" marL="0" marR="0" indent="0"/>
+            <a:r>
+              <a:rPr lang="en-US" sz="4225" dirty="0" smtClean="0">
                 <a:solidFill>
                   <a:srgbClr val="FFFFFF"/>
                 </a:solidFill>
@@ -1147,14 +1147,14 @@
           </a:solidFill>
         </p:spPr>
         <p:txBody>
-          <a:bodyPr wrap="square" rtlCol="0" anchor="ctr">
-            <a:normAutofit/>
+          <a:bodyPr wrap="square" rtlCol="0" anchor="ctr" lIns="91440" tIns="45720" rIns="91440" bIns="45720">
+            <a:normAutofit fontScale="100000" lnSpcReduction="0"/>
           </a:bodyPr>
           <a:lstStyle/>
           <a:p>
-            <a:pPr algn="ctr"/>
-            <a:r>
-              <a:rPr lang="en-US" sz="4400" dirty="0">
+            <a:pPr algn="ctr" marL="0" marR="0" indent="0"/>
+            <a:r>
+              <a:rPr lang="en-US" sz="4225" dirty="0" smtClean="0">
                 <a:solidFill>
                   <a:srgbClr val="000000"/>
                 </a:solidFill>
@@ -2519,14 +2519,14 @@
           </a:solidFill>
         </p:spPr>
         <p:txBody>
-          <a:bodyPr wrap="square" rtlCol="0" anchor="ctr">
-            <a:normAutofit/>
+          <a:bodyPr wrap="square" rtlCol="0" anchor="ctr" lIns="91440" tIns="45720" rIns="91440" bIns="45720">
+            <a:normAutofit fontScale="100000" lnSpcReduction="0"/>
           </a:bodyPr>
           <a:lstStyle/>
           <a:p>
-            <a:pPr algn="ctr"/>
-            <a:r>
-              <a:rPr lang="en-US" sz="2004" dirty="0">
+            <a:pPr algn="ctr" marL="0" marR="0" indent="0"/>
+            <a:r>
+              <a:rPr lang="en-US" sz="1742" dirty="0" smtClean="0">
                 <a:solidFill>
                   <a:srgbClr val="FFFFFF"/>
                 </a:solidFill>
@@ -2579,14 +2579,14 @@
           </a:solidFill>
         </p:spPr>
         <p:txBody>
-          <a:bodyPr wrap="square" rtlCol="0" anchor="ctr">
-            <a:normAutofit/>
+          <a:bodyPr wrap="square" rtlCol="0" anchor="ctr" lIns="91440" tIns="45720" rIns="91440" bIns="45720">
+            <a:normAutofit fontScale="100000" lnSpcReduction="0"/>
           </a:bodyPr>
           <a:lstStyle/>
           <a:p>
-            <a:pPr algn="ctr"/>
-            <a:r>
-              <a:rPr lang="en-US" sz="2449" dirty="0">
+            <a:pPr algn="ctr" marL="0" marR="0" indent="0"/>
+            <a:r>
+              <a:rPr lang="en-US" sz="2129" dirty="0" smtClean="0">
                 <a:solidFill>
                   <a:srgbClr val="000000"/>
                 </a:solidFill>
@@ -2639,14 +2639,14 @@
           </a:solidFill>
         </p:spPr>
         <p:txBody>
-          <a:bodyPr wrap="square" rtlCol="0" anchor="ctr">
-            <a:normAutofit/>
+          <a:bodyPr wrap="square" rtlCol="0" anchor="ctr" lIns="91440" tIns="45720" rIns="91440" bIns="45720">
+            <a:normAutofit fontScale="100000" lnSpcReduction="0"/>
           </a:bodyPr>
           <a:lstStyle/>
           <a:p>
-            <a:pPr algn="ctr"/>
-            <a:r>
-              <a:rPr lang="en-US" sz="2204" dirty="0">
+            <a:pPr algn="ctr" marL="0" marR="0" indent="0"/>
+            <a:r>
+              <a:rPr lang="en-US" sz="1916" dirty="0" smtClean="0">
                 <a:solidFill>
                   <a:srgbClr val="000000"/>
                 </a:solidFill>
@@ -2699,14 +2699,14 @@
           </a:solidFill>
         </p:spPr>
         <p:txBody>
-          <a:bodyPr wrap="square" rtlCol="0" anchor="ctr">
-            <a:normAutofit/>
+          <a:bodyPr wrap="square" rtlCol="0" anchor="ctr" lIns="91440" tIns="45720" rIns="91440" bIns="45720">
+            <a:normAutofit fontScale="100000" lnSpcReduction="0"/>
           </a:bodyPr>
           <a:lstStyle/>
           <a:p>
-            <a:pPr algn="ctr"/>
-            <a:r>
-              <a:rPr lang="en-US" sz="2449" dirty="0">
+            <a:pPr algn="ctr" marL="0" marR="0" indent="0"/>
+            <a:r>
+              <a:rPr lang="en-US" sz="2129" dirty="0" smtClean="0">
                 <a:solidFill>
                   <a:srgbClr val="000000"/>
                 </a:solidFill>
@@ -2797,14 +2797,14 @@
           </a:solidFill>
         </p:spPr>
         <p:txBody>
-          <a:bodyPr wrap="square" rtlCol="0" anchor="ctr">
-            <a:normAutofit/>
+          <a:bodyPr wrap="square" rtlCol="0" anchor="ctr" lIns="91440" tIns="45720" rIns="91440" bIns="45720">
+            <a:normAutofit fontScale="100000" lnSpcReduction="0"/>
           </a:bodyPr>
           <a:lstStyle/>
           <a:p>
-            <a:pPr algn="ctr"/>
-            <a:r>
-              <a:rPr lang="en-US" sz="3779" dirty="0">
+            <a:pPr algn="ctr" marL="0" marR="0" indent="0"/>
+            <a:r>
+              <a:rPr lang="en-US" sz="2856" dirty="0" smtClean="0">
                 <a:solidFill>
                   <a:srgbClr val="FFFFFF"/>
                 </a:solidFill>
@@ -2881,14 +2881,14 @@
           </a:solidFill>
         </p:spPr>
         <p:txBody>
-          <a:bodyPr wrap="square" rtlCol="0" anchor="ctr">
-            <a:normAutofit/>
+          <a:bodyPr wrap="square" rtlCol="0" anchor="ctr" lIns="91440" tIns="45720" rIns="91440" bIns="45720">
+            <a:normAutofit fontScale="100000" lnSpcReduction="0"/>
           </a:bodyPr>
           <a:lstStyle/>
           <a:p>
-            <a:pPr algn="ctr"/>
-            <a:r>
-              <a:rPr lang="en-US" sz="3149" dirty="0">
+            <a:pPr algn="ctr" marL="0" marR="0" indent="0"/>
+            <a:r>
+              <a:rPr lang="en-US" sz="2171" dirty="0" smtClean="0">
                 <a:solidFill>
                   <a:srgbClr val="FFFFFF"/>
                 </a:solidFill>
@@ -2917,14 +2917,14 @@
           </a:solidFill>
         </p:spPr>
         <p:txBody>
-          <a:bodyPr wrap="square" rtlCol="0" anchor="ctr">
-            <a:normAutofit/>
+          <a:bodyPr wrap="square" rtlCol="0" anchor="ctr" lIns="91440" tIns="45720" rIns="91440" bIns="45720">
+            <a:normAutofit fontScale="100000" lnSpcReduction="0"/>
           </a:bodyPr>
           <a:lstStyle/>
           <a:p>
-            <a:pPr algn="ctr"/>
-            <a:r>
-              <a:rPr lang="en-US" sz="3149" dirty="0">
+            <a:pPr algn="ctr" marL="0" marR="0" indent="0"/>
+            <a:r>
+              <a:rPr lang="en-US" sz="2171" dirty="0" smtClean="0">
                 <a:solidFill>
                   <a:srgbClr val="FFFFFF"/>
                 </a:solidFill>
@@ -2953,14 +2953,14 @@
           </a:solidFill>
         </p:spPr>
         <p:txBody>
-          <a:bodyPr wrap="square" rtlCol="0" anchor="ctr">
-            <a:normAutofit/>
+          <a:bodyPr wrap="square" rtlCol="0" anchor="ctr" lIns="91440" tIns="45720" rIns="91440" bIns="45720">
+            <a:normAutofit fontScale="100000" lnSpcReduction="0"/>
           </a:bodyPr>
           <a:lstStyle/>
           <a:p>
-            <a:pPr algn="ctr"/>
-            <a:r>
-              <a:rPr lang="en-US" sz="3149" dirty="0">
+            <a:pPr algn="ctr" marL="0" marR="0" indent="0"/>
+            <a:r>
+              <a:rPr lang="en-US" sz="2171" dirty="0" smtClean="0">
                 <a:solidFill>
                   <a:srgbClr val="FFFFFF"/>
                 </a:solidFill>
@@ -3061,14 +3061,14 @@
           </a:solidFill>
         </p:spPr>
         <p:txBody>
-          <a:bodyPr wrap="square" rtlCol="0" anchor="ctr">
-            <a:normAutofit/>
+          <a:bodyPr wrap="square" rtlCol="0" anchor="ctr" lIns="91440" tIns="45720" rIns="91440" bIns="45720">
+            <a:normAutofit fontScale="100000" lnSpcReduction="0"/>
           </a:bodyPr>
           <a:lstStyle/>
           <a:p>
-            <a:pPr algn="ctr"/>
-            <a:r>
-              <a:rPr lang="en-US" sz="1717" dirty="0">
+            <a:pPr algn="ctr" marL="0" marR="0" indent="0"/>
+            <a:r>
+              <a:rPr lang="en-US" sz="1456" dirty="0" smtClean="0">
                 <a:solidFill>
                   <a:srgbClr val="000000"/>
                 </a:solidFill>
@@ -3097,14 +3097,14 @@
           </a:solidFill>
         </p:spPr>
         <p:txBody>
-          <a:bodyPr wrap="square" rtlCol="0" anchor="ctr">
-            <a:normAutofit/>
+          <a:bodyPr wrap="square" rtlCol="0" anchor="ctr" lIns="91440" tIns="45720" rIns="91440" bIns="45720">
+            <a:normAutofit fontScale="100000" lnSpcReduction="0"/>
           </a:bodyPr>
           <a:lstStyle/>
           <a:p>
-            <a:pPr algn="ctr"/>
-            <a:r>
-              <a:rPr lang="en-US" sz="2519" dirty="0">
+            <a:pPr algn="ctr" marL="0" marR="0" indent="0"/>
+            <a:r>
+              <a:rPr lang="en-US" sz="1486" dirty="0" smtClean="0">
                 <a:solidFill>
                   <a:srgbClr val="000000"/>
                 </a:solidFill>
@@ -3195,14 +3195,14 @@
           </a:solidFill>
         </p:spPr>
         <p:txBody>
-          <a:bodyPr wrap="square" rtlCol="0" anchor="t">
-            <a:normAutofit/>
+          <a:bodyPr wrap="square" rtlCol="0" anchor="t" lIns="91440" tIns="45720" rIns="91440" bIns="45720">
+            <a:normAutofit fontScale="100000" lnSpcReduction="0"/>
           </a:bodyPr>
           <a:lstStyle/>
           <a:p>
-            <a:pPr algn="l"/>
-            <a:r>
-              <a:rPr lang="en-US" sz="2362" dirty="0">
+            <a:pPr algn="l" marL="0" marR="0" indent="0"/>
+            <a:r>
+              <a:rPr lang="en-US" sz="2254" dirty="0" smtClean="0">
                 <a:solidFill>
                   <a:srgbClr val="FFFFFF"/>
                 </a:solidFill>
@@ -3233,14 +3233,14 @@
           </a:solidFill>
         </p:spPr>
         <p:txBody>
-          <a:bodyPr wrap="square" rtlCol="0" anchor="t">
-            <a:normAutofit/>
+          <a:bodyPr wrap="square" rtlCol="0" anchor="t" lIns="91440" tIns="45720" rIns="91440" bIns="45720">
+            <a:normAutofit fontScale="100000" lnSpcReduction="0"/>
           </a:bodyPr>
           <a:lstStyle/>
           <a:p>
-            <a:pPr algn="l"/>
-            <a:r>
-              <a:rPr lang="en-US" sz="2362" dirty="0">
+            <a:pPr algn="l" marL="0" marR="0" indent="0"/>
+            <a:r>
+              <a:rPr lang="en-US" sz="2254" dirty="0" smtClean="0">
                 <a:solidFill>
                   <a:srgbClr val="000000"/>
                 </a:solidFill>
@@ -3271,14 +3271,14 @@
           </a:solidFill>
         </p:spPr>
         <p:txBody>
-          <a:bodyPr wrap="square" rtlCol="0" anchor="t">
-            <a:normAutofit/>
+          <a:bodyPr wrap="square" rtlCol="0" anchor="t" lIns="91440" tIns="45720" rIns="91440" bIns="45720">
+            <a:normAutofit fontScale="100000" lnSpcReduction="0"/>
           </a:bodyPr>
           <a:lstStyle/>
           <a:p>
-            <a:pPr algn="l"/>
-            <a:r>
-              <a:rPr lang="en-US" sz="2362" dirty="0">
+            <a:pPr algn="l" marL="0" marR="0" indent="0"/>
+            <a:r>
+              <a:rPr lang="en-US" sz="2254" dirty="0" smtClean="0">
                 <a:solidFill>
                   <a:srgbClr val="000000"/>
                 </a:solidFill>
@@ -3309,14 +3309,14 @@
           </a:solidFill>
         </p:spPr>
         <p:txBody>
-          <a:bodyPr wrap="square" rtlCol="0" anchor="t">
-            <a:normAutofit/>
+          <a:bodyPr wrap="square" rtlCol="0" anchor="t" lIns="91440" tIns="45720" rIns="91440" bIns="45720">
+            <a:normAutofit fontScale="100000" lnSpcReduction="0"/>
           </a:bodyPr>
           <a:lstStyle/>
           <a:p>
-            <a:pPr algn="l"/>
-            <a:r>
-              <a:rPr lang="en-US" sz="2362" dirty="0">
+            <a:pPr algn="l" marL="0" marR="0" indent="0"/>
+            <a:r>
+              <a:rPr lang="en-US" sz="2254" dirty="0" smtClean="0">
                 <a:solidFill>
                   <a:srgbClr val="000000"/>
                 </a:solidFill>
@@ -3505,14 +3505,14 @@
           </a:solidFill>
         </p:spPr>
         <p:txBody>
-          <a:bodyPr wrap="square" rtlCol="0" anchor="ctr">
-            <a:normAutofit/>
+          <a:bodyPr wrap="square" rtlCol="0" anchor="ctr" lIns="91440" tIns="45720" rIns="91440" bIns="45720">
+            <a:normAutofit fontScale="100000" lnSpcReduction="0"/>
           </a:bodyPr>
           <a:lstStyle/>
           <a:p>
-            <a:pPr algn="ctr"/>
-            <a:r>
-              <a:rPr lang="en-US" sz="2999" dirty="0">
+            <a:pPr algn="ctr" marL="0" marR="0" indent="0"/>
+            <a:r>
+              <a:rPr lang="en-US" sz="2380" dirty="0" smtClean="0">
                 <a:solidFill>
                   <a:srgbClr val="FFFFFF"/>
                 </a:solidFill>
@@ -3541,14 +3541,14 @@
           </a:solidFill>
         </p:spPr>
         <p:txBody>
-          <a:bodyPr wrap="square" rtlCol="0" anchor="ctr">
-            <a:normAutofit/>
+          <a:bodyPr wrap="square" rtlCol="0" anchor="ctr" lIns="91440" tIns="45720" rIns="91440" bIns="45720">
+            <a:normAutofit fontScale="100000" lnSpcReduction="0"/>
           </a:bodyPr>
           <a:lstStyle/>
           <a:p>
-            <a:pPr algn="ctr"/>
-            <a:r>
-              <a:rPr lang="en-US" sz="3242" dirty="0">
+            <a:pPr algn="ctr" marL="0" marR="0" indent="0"/>
+            <a:r>
+              <a:rPr lang="en-US" sz="2380" dirty="0" smtClean="0">
                 <a:solidFill>
                   <a:srgbClr val="000000"/>
                 </a:solidFill>
@@ -3577,14 +3577,14 @@
           </a:solidFill>
         </p:spPr>
         <p:txBody>
-          <a:bodyPr wrap="square" rtlCol="0" anchor="ctr">
-            <a:normAutofit/>
+          <a:bodyPr wrap="square" rtlCol="0" anchor="ctr" lIns="91440" tIns="45720" rIns="91440" bIns="45720">
+            <a:normAutofit fontScale="100000" lnSpcReduction="0"/>
           </a:bodyPr>
           <a:lstStyle/>
           <a:p>
-            <a:pPr algn="ctr"/>
-            <a:r>
-              <a:rPr lang="en-US" sz="2952" dirty="0">
+            <a:pPr algn="ctr" marL="0" marR="0" indent="0"/>
+            <a:r>
+              <a:rPr lang="en-US" sz="2380" dirty="0" smtClean="0">
                 <a:solidFill>
                   <a:srgbClr val="000000"/>
                 </a:solidFill>
@@ -3613,14 +3613,14 @@
           </a:solidFill>
         </p:spPr>
         <p:txBody>
-          <a:bodyPr wrap="square" rtlCol="0" anchor="ctr">
-            <a:normAutofit/>
+          <a:bodyPr wrap="square" rtlCol="0" anchor="ctr" lIns="91440" tIns="45720" rIns="91440" bIns="45720">
+            <a:normAutofit fontScale="100000" lnSpcReduction="0"/>
           </a:bodyPr>
           <a:lstStyle/>
           <a:p>
-            <a:pPr algn="ctr"/>
-            <a:r>
-              <a:rPr lang="en-US" sz="2715" dirty="0">
+            <a:pPr algn="ctr" marL="0" marR="0" indent="0"/>
+            <a:r>
+              <a:rPr lang="en-US" sz="2615" dirty="0" smtClean="0">
                 <a:solidFill>
                   <a:srgbClr val="000000"/>
                 </a:solidFill>
@@ -3649,14 +3649,14 @@
           </a:solidFill>
         </p:spPr>
         <p:txBody>
-          <a:bodyPr wrap="square" rtlCol="0" anchor="ctr">
-            <a:normAutofit/>
+          <a:bodyPr wrap="square" rtlCol="0" anchor="ctr" lIns="91440" tIns="45720" rIns="91440" bIns="45720">
+            <a:normAutofit fontScale="100000" lnSpcReduction="0"/>
           </a:bodyPr>
           <a:lstStyle/>
           <a:p>
-            <a:pPr algn="ctr"/>
-            <a:r>
-              <a:rPr lang="en-US" sz="3499" dirty="0">
+            <a:pPr algn="ctr" marL="0" marR="0" indent="0"/>
+            <a:r>
+              <a:rPr lang="en-US" sz="3339" dirty="0" smtClean="0">
                 <a:solidFill>
                   <a:srgbClr val="FFFFFF"/>
                 </a:solidFill>
@@ -3809,14 +3809,14 @@
           </a:solidFill>
         </p:spPr>
         <p:txBody>
-          <a:bodyPr wrap="square" rtlCol="0" anchor="ctr">
-            <a:normAutofit/>
+          <a:bodyPr wrap="square" rtlCol="0" anchor="ctr" lIns="91440" tIns="45720" rIns="91440" bIns="45720">
+            <a:normAutofit fontScale="100000" lnSpcReduction="0"/>
           </a:bodyPr>
           <a:lstStyle/>
           <a:p>
-            <a:pPr algn="ctr"/>
-            <a:r>
-              <a:rPr lang="en-US" sz="4400" dirty="0">
+            <a:pPr algn="ctr" marL="0" marR="0" indent="0"/>
+            <a:r>
+              <a:rPr lang="en-US" sz="7200" dirty="0" smtClean="0">
                 <a:solidFill>
                   <a:srgbClr val="FFFFFF"/>
                 </a:solidFill>
@@ -3845,14 +3845,14 @@
           </a:solidFill>
         </p:spPr>
         <p:txBody>
-          <a:bodyPr wrap="square" rtlCol="0" anchor="ctr">
-            <a:normAutofit/>
+          <a:bodyPr wrap="square" rtlCol="0" anchor="ctr" lIns="91440" tIns="45720" rIns="91440" bIns="45720">
+            <a:normAutofit fontScale="100000" lnSpcReduction="0"/>
           </a:bodyPr>
           <a:lstStyle/>
           <a:p>
-            <a:pPr algn="ctr"/>
-            <a:r>
-              <a:rPr lang="en-US" sz="4400" dirty="0">
+            <a:pPr algn="ctr" marL="0" marR="0" indent="0"/>
+            <a:r>
+              <a:rPr lang="en-US" sz="6337" dirty="0" smtClean="0">
                 <a:solidFill>
                   <a:srgbClr val="000000"/>
                 </a:solidFill>
@@ -3881,14 +3881,14 @@
           </a:solidFill>
         </p:spPr>
         <p:txBody>
-          <a:bodyPr wrap="square" rtlCol="0" anchor="ctr">
-            <a:normAutofit/>
+          <a:bodyPr wrap="square" rtlCol="0" anchor="ctr" lIns="91440" tIns="45720" rIns="91440" bIns="45720">
+            <a:normAutofit fontScale="100000" lnSpcReduction="0"/>
           </a:bodyPr>
           <a:lstStyle/>
           <a:p>
-            <a:pPr algn="ctr"/>
-            <a:r>
-              <a:rPr lang="en-US" sz="4294" dirty="0">
+            <a:pPr algn="ctr" marL="0" marR="0" indent="0"/>
+            <a:r>
+              <a:rPr lang="en-US" sz="4033" dirty="0" smtClean="0">
                 <a:solidFill>
                   <a:srgbClr val="000000"/>
                 </a:solidFill>
@@ -3917,14 +3917,14 @@
           </a:solidFill>
         </p:spPr>
         <p:txBody>
-          <a:bodyPr wrap="square" rtlCol="0" anchor="ctr">
-            <a:normAutofit/>
+          <a:bodyPr wrap="square" rtlCol="0" anchor="ctr" lIns="91440" tIns="45720" rIns="91440" bIns="45720">
+            <a:normAutofit fontScale="100000" lnSpcReduction="0"/>
           </a:bodyPr>
           <a:lstStyle/>
           <a:p>
-            <a:pPr algn="ctr"/>
-            <a:r>
-              <a:rPr lang="en-US" sz="4199" dirty="0">
+            <a:pPr algn="ctr" marL="0" marR="0" indent="0"/>
+            <a:r>
+              <a:rPr lang="en-US" sz="3719" dirty="0" smtClean="0">
                 <a:solidFill>
                   <a:srgbClr val="000000"/>
                 </a:solidFill>
@@ -4408,14 +4408,14 @@
           </a:solidFill>
         </p:spPr>
         <p:txBody>
-          <a:bodyPr wrap="square" rtlCol="0" anchor="t">
-            <a:normAutofit/>
+          <a:bodyPr wrap="square" rtlCol="0" anchor="t" lIns="91440" tIns="45720" rIns="91440" bIns="45720">
+            <a:normAutofit fontScale="100000" lnSpcReduction="0"/>
           </a:bodyPr>
           <a:lstStyle/>
           <a:p>
-            <a:pPr algn="l"/>
-            <a:r>
-              <a:rPr lang="en-US" sz="1944" dirty="0">
+            <a:pPr algn="l" marL="0" marR="0" indent="0"/>
+            <a:r>
+              <a:rPr lang="en-US" sz="1800" dirty="0" smtClean="0">
                 <a:solidFill>
                   <a:srgbClr val="FFFFFF"/>
                 </a:solidFill>
@@ -4446,14 +4446,14 @@
           </a:solidFill>
         </p:spPr>
         <p:txBody>
-          <a:bodyPr wrap="square" rtlCol="0" anchor="t">
-            <a:normAutofit/>
+          <a:bodyPr wrap="square" rtlCol="0" anchor="t" lIns="91440" tIns="45720" rIns="91440" bIns="45720">
+            <a:normAutofit fontScale="100000" lnSpcReduction="0"/>
           </a:bodyPr>
           <a:lstStyle/>
           <a:p>
-            <a:pPr algn="l"/>
-            <a:r>
-              <a:rPr lang="en-US" sz="1944" dirty="0">
+            <a:pPr algn="l" marL="0" marR="0" indent="0"/>
+            <a:r>
+              <a:rPr lang="en-US" sz="1800" dirty="0" smtClean="0">
                 <a:solidFill>
                   <a:srgbClr val="000000"/>
                 </a:solidFill>
@@ -4484,14 +4484,14 @@
           </a:solidFill>
         </p:spPr>
         <p:txBody>
-          <a:bodyPr wrap="square" rtlCol="0" anchor="t">
-            <a:normAutofit/>
+          <a:bodyPr wrap="square" rtlCol="0" anchor="t" lIns="91440" tIns="45720" rIns="91440" bIns="45720">
+            <a:normAutofit fontScale="100000" lnSpcReduction="0"/>
           </a:bodyPr>
           <a:lstStyle/>
           <a:p>
-            <a:pPr algn="l"/>
-            <a:r>
-              <a:rPr lang="en-US" sz="1944" dirty="0">
+            <a:pPr algn="l" marL="0" marR="0" indent="0"/>
+            <a:r>
+              <a:rPr lang="en-US" sz="1800" dirty="0" smtClean="0">
                 <a:solidFill>
                   <a:srgbClr val="000000"/>
                 </a:solidFill>
@@ -4522,14 +4522,14 @@
           </a:solidFill>
         </p:spPr>
         <p:txBody>
-          <a:bodyPr wrap="square" rtlCol="0" anchor="t">
-            <a:normAutofit/>
+          <a:bodyPr wrap="square" rtlCol="0" anchor="t" lIns="91440" tIns="45720" rIns="91440" bIns="45720">
+            <a:normAutofit fontScale="100000" lnSpcReduction="0"/>
           </a:bodyPr>
           <a:lstStyle/>
           <a:p>
-            <a:pPr algn="l"/>
-            <a:r>
-              <a:rPr lang="en-US" sz="1944" dirty="0">
+            <a:pPr algn="l" marL="0" marR="0" indent="0"/>
+            <a:r>
+              <a:rPr lang="en-US" sz="1800" dirty="0" smtClean="0">
                 <a:solidFill>
                   <a:srgbClr val="000000"/>
                 </a:solidFill>
@@ -5911,14 +5911,14 @@
           </a:solidFill>
         </p:spPr>
         <p:txBody>
-          <a:bodyPr wrap="square" rtlCol="0" anchor="ctr">
-            <a:normAutofit/>
+          <a:bodyPr wrap="square" rtlCol="0" anchor="ctr" lIns="91440" tIns="45720" rIns="91440" bIns="45720">
+            <a:normAutofit fontScale="100000" lnSpcReduction="0"/>
           </a:bodyPr>
           <a:lstStyle/>
           <a:p>
-            <a:pPr algn="ctr"/>
-            <a:r>
-              <a:rPr lang="en-US" sz="3149" dirty="0">
+            <a:pPr algn="ctr" marL="0" marR="0" indent="0"/>
+            <a:r>
+              <a:rPr lang="en-US" sz="2829" dirty="0" smtClean="0">
                 <a:solidFill>
                   <a:srgbClr val="FFFFFF"/>
                 </a:solidFill>
@@ -5947,14 +5947,14 @@
           </a:solidFill>
         </p:spPr>
         <p:txBody>
-          <a:bodyPr wrap="square" rtlCol="0" anchor="ctr">
-            <a:normAutofit/>
+          <a:bodyPr wrap="square" rtlCol="0" anchor="ctr" lIns="91440" tIns="45720" rIns="91440" bIns="45720">
+            <a:normAutofit fontScale="100000" lnSpcReduction="0"/>
           </a:bodyPr>
           <a:lstStyle/>
           <a:p>
-            <a:pPr algn="ctr"/>
-            <a:r>
-              <a:rPr lang="en-US" sz="4400" dirty="0">
+            <a:pPr algn="ctr" marL="0" marR="0" indent="0"/>
+            <a:r>
+              <a:rPr lang="en-US" sz="4225" dirty="0" smtClean="0">
                 <a:solidFill>
                   <a:srgbClr val="FFFFFF"/>
                 </a:solidFill>
@@ -5983,14 +5983,14 @@
           </a:solidFill>
         </p:spPr>
         <p:txBody>
-          <a:bodyPr wrap="square" rtlCol="0" anchor="ctr">
-            <a:normAutofit/>
+          <a:bodyPr wrap="square" rtlCol="0" anchor="ctr" lIns="91440" tIns="45720" rIns="91440" bIns="45720">
+            <a:normAutofit fontScale="100000" lnSpcReduction="0"/>
           </a:bodyPr>
           <a:lstStyle/>
           <a:p>
-            <a:pPr algn="ctr"/>
-            <a:r>
-              <a:rPr lang="en-US" sz="4049" dirty="0">
+            <a:pPr algn="ctr" marL="0" marR="0" indent="0"/>
+            <a:r>
+              <a:rPr lang="en-US" sz="3638" dirty="0" smtClean="0">
                 <a:solidFill>
                   <a:srgbClr val="FFFFFF"/>
                 </a:solidFill>
@@ -6019,14 +6019,14 @@
           </a:solidFill>
         </p:spPr>
         <p:txBody>
-          <a:bodyPr wrap="square" rtlCol="0" anchor="ctr">
-            <a:normAutofit/>
+          <a:bodyPr wrap="square" rtlCol="0" anchor="ctr" lIns="91440" tIns="45720" rIns="91440" bIns="45720">
+            <a:normAutofit fontScale="100000" lnSpcReduction="0"/>
           </a:bodyPr>
           <a:lstStyle/>
           <a:p>
-            <a:pPr algn="ctr"/>
-            <a:r>
-              <a:rPr lang="en-US" sz="4400" dirty="0">
+            <a:pPr algn="ctr" marL="0" marR="0" indent="0"/>
+            <a:r>
+              <a:rPr lang="en-US" sz="4225" dirty="0" smtClean="0">
                 <a:solidFill>
                   <a:srgbClr val="000000"/>
                 </a:solidFill>
@@ -6055,14 +6055,14 @@
           </a:solidFill>
         </p:spPr>
         <p:txBody>
-          <a:bodyPr wrap="square" rtlCol="0" anchor="ctr">
-            <a:normAutofit/>
+          <a:bodyPr wrap="square" rtlCol="0" anchor="ctr" lIns="91440" tIns="45720" rIns="91440" bIns="45720">
+            <a:normAutofit fontScale="100000" lnSpcReduction="0"/>
           </a:bodyPr>
           <a:lstStyle/>
           <a:p>
-            <a:pPr algn="ctr"/>
-            <a:r>
-              <a:rPr lang="en-US" sz="4400" dirty="0">
+            <a:pPr algn="ctr" marL="0" marR="0" indent="0"/>
+            <a:r>
+              <a:rPr lang="en-US" sz="4225" dirty="0" smtClean="0">
                 <a:solidFill>
                   <a:srgbClr val="FFFFFF"/>
                 </a:solidFill>
@@ -6091,14 +6091,14 @@
           </a:solidFill>
         </p:spPr>
         <p:txBody>
-          <a:bodyPr wrap="square" rtlCol="0" anchor="ctr">
-            <a:normAutofit/>
+          <a:bodyPr wrap="square" rtlCol="0" anchor="ctr" lIns="91440" tIns="45720" rIns="91440" bIns="45720">
+            <a:normAutofit fontScale="100000" lnSpcReduction="0"/>
           </a:bodyPr>
           <a:lstStyle/>
           <a:p>
-            <a:pPr algn="ctr"/>
-            <a:r>
-              <a:rPr lang="en-US" sz="4400" dirty="0">
+            <a:pPr algn="ctr" marL="0" marR="0" indent="0"/>
+            <a:r>
+              <a:rPr lang="en-US" sz="4225" dirty="0" smtClean="0">
                 <a:solidFill>
                   <a:srgbClr val="FFFFFF"/>
                 </a:solidFill>
@@ -6127,14 +6127,14 @@
           </a:solidFill>
         </p:spPr>
         <p:txBody>
-          <a:bodyPr wrap="square" rtlCol="0" anchor="ctr">
-            <a:normAutofit/>
+          <a:bodyPr wrap="square" rtlCol="0" anchor="ctr" lIns="91440" tIns="45720" rIns="91440" bIns="45720">
+            <a:normAutofit fontScale="100000" lnSpcReduction="0"/>
           </a:bodyPr>
           <a:lstStyle/>
           <a:p>
-            <a:pPr algn="ctr"/>
-            <a:r>
-              <a:rPr lang="en-US" sz="4400" dirty="0">
+            <a:pPr algn="ctr" marL="0" marR="0" indent="0"/>
+            <a:r>
+              <a:rPr lang="en-US" sz="4225" dirty="0" smtClean="0">
                 <a:solidFill>
                   <a:srgbClr val="FFFFFF"/>
                 </a:solidFill>
@@ -6225,14 +6225,14 @@
           </a:solidFill>
         </p:spPr>
         <p:txBody>
-          <a:bodyPr wrap="square" rtlCol="0" anchor="ctr">
-            <a:normAutofit/>
+          <a:bodyPr wrap="square" rtlCol="0" anchor="ctr" lIns="91440" tIns="45720" rIns="91440" bIns="45720">
+            <a:normAutofit fontScale="100000" lnSpcReduction="0"/>
           </a:bodyPr>
           <a:lstStyle/>
           <a:p>
-            <a:pPr algn="ctr"/>
-            <a:r>
-              <a:rPr lang="en-US" sz="3779" dirty="0">
+            <a:pPr algn="ctr" marL="0" marR="0" indent="0"/>
+            <a:r>
+              <a:rPr lang="en-US" sz="2856" dirty="0" smtClean="0">
                 <a:solidFill>
                   <a:srgbClr val="FFFFFF"/>
                 </a:solidFill>
@@ -6261,14 +6261,14 @@
           </a:solidFill>
         </p:spPr>
         <p:txBody>
-          <a:bodyPr wrap="square" rtlCol="0" anchor="ctr">
-            <a:normAutofit/>
+          <a:bodyPr wrap="square" rtlCol="0" anchor="ctr" lIns="91440" tIns="45720" rIns="91440" bIns="45720">
+            <a:normAutofit fontScale="100000" lnSpcReduction="0"/>
           </a:bodyPr>
           <a:lstStyle/>
           <a:p>
-            <a:pPr algn="ctr"/>
-            <a:r>
-              <a:rPr lang="en-US" sz="3149" dirty="0">
+            <a:pPr algn="ctr" marL="0" marR="0" indent="0"/>
+            <a:r>
+              <a:rPr lang="en-US" sz="2669" dirty="0" smtClean="0">
                 <a:solidFill>
                   <a:srgbClr val="FFFFFF"/>
                 </a:solidFill>
@@ -6297,14 +6297,14 @@
           </a:solidFill>
         </p:spPr>
         <p:txBody>
-          <a:bodyPr wrap="square" rtlCol="0" anchor="ctr">
-            <a:normAutofit/>
+          <a:bodyPr wrap="square" rtlCol="0" anchor="ctr" lIns="91440" tIns="45720" rIns="91440" bIns="45720">
+            <a:normAutofit fontScale="100000" lnSpcReduction="0"/>
           </a:bodyPr>
           <a:lstStyle/>
           <a:p>
-            <a:pPr algn="ctr"/>
-            <a:r>
-              <a:rPr lang="en-US" sz="2699" dirty="0">
+            <a:pPr algn="ctr" marL="0" marR="0" indent="0"/>
+            <a:r>
+              <a:rPr lang="en-US" sz="2288" dirty="0" smtClean="0">
                 <a:solidFill>
                   <a:srgbClr val="000000"/>
                 </a:solidFill>
@@ -6333,14 +6333,14 @@
           </a:solidFill>
         </p:spPr>
         <p:txBody>
-          <a:bodyPr wrap="square" rtlCol="0" anchor="ctr">
-            <a:normAutofit/>
+          <a:bodyPr wrap="square" rtlCol="0" anchor="ctr" lIns="91440" tIns="45720" rIns="91440" bIns="45720">
+            <a:normAutofit fontScale="100000" lnSpcReduction="0"/>
           </a:bodyPr>
           <a:lstStyle/>
           <a:p>
-            <a:pPr algn="ctr"/>
-            <a:r>
-              <a:rPr lang="en-US" sz="2362" dirty="0">
+            <a:pPr algn="ctr" marL="0" marR="0" indent="0"/>
+            <a:r>
+              <a:rPr lang="en-US" sz="2002" dirty="0" smtClean="0">
                 <a:solidFill>
                   <a:srgbClr val="000000"/>
                 </a:solidFill>
@@ -6369,14 +6369,14 @@
           </a:solidFill>
         </p:spPr>
         <p:txBody>
-          <a:bodyPr wrap="square" rtlCol="0" anchor="ctr">
-            <a:normAutofit/>
+          <a:bodyPr wrap="square" rtlCol="0" anchor="ctr" lIns="91440" tIns="45720" rIns="91440" bIns="45720">
+            <a:normAutofit fontScale="100000" lnSpcReduction="0"/>
           </a:bodyPr>
           <a:lstStyle/>
           <a:p>
-            <a:pPr algn="ctr"/>
-            <a:r>
-              <a:rPr lang="en-US" sz="2362" dirty="0">
+            <a:pPr algn="ctr" marL="0" marR="0" indent="0"/>
+            <a:r>
+              <a:rPr lang="en-US" sz="2002" dirty="0" smtClean="0">
                 <a:solidFill>
                   <a:srgbClr val="FFFFFF"/>
                 </a:solidFill>
@@ -6405,14 +6405,14 @@
           </a:solidFill>
         </p:spPr>
         <p:txBody>
-          <a:bodyPr wrap="square" rtlCol="0" anchor="ctr">
-            <a:normAutofit/>
+          <a:bodyPr wrap="square" rtlCol="0" anchor="ctr" lIns="91440" tIns="45720" rIns="91440" bIns="45720">
+            <a:normAutofit fontScale="100000" lnSpcReduction="0"/>
           </a:bodyPr>
           <a:lstStyle/>
           <a:p>
-            <a:pPr algn="ctr"/>
-            <a:r>
-              <a:rPr lang="en-US" sz="3149" dirty="0">
+            <a:pPr algn="ctr" marL="0" marR="0" indent="0"/>
+            <a:r>
+              <a:rPr lang="en-US" sz="2669" dirty="0" smtClean="0">
                 <a:solidFill>
                   <a:srgbClr val="FFFFFF"/>
                 </a:solidFill>
@@ -6441,14 +6441,14 @@
           </a:solidFill>
         </p:spPr>
         <p:txBody>
-          <a:bodyPr wrap="square" rtlCol="0" anchor="ctr">
-            <a:normAutofit/>
+          <a:bodyPr wrap="square" rtlCol="0" anchor="ctr" lIns="91440" tIns="45720" rIns="91440" bIns="45720">
+            <a:normAutofit fontScale="100000" lnSpcReduction="0"/>
           </a:bodyPr>
           <a:lstStyle/>
           <a:p>
-            <a:pPr algn="ctr"/>
-            <a:r>
-              <a:rPr lang="en-US" sz="2699" dirty="0">
+            <a:pPr algn="ctr" marL="0" marR="0" indent="0"/>
+            <a:r>
+              <a:rPr lang="en-US" sz="2288" dirty="0" smtClean="0">
                 <a:solidFill>
                   <a:srgbClr val="FFFFFF"/>
                 </a:solidFill>
@@ -6477,14 +6477,14 @@
           </a:solidFill>
         </p:spPr>
         <p:txBody>
-          <a:bodyPr wrap="square" rtlCol="0" anchor="ctr">
-            <a:normAutofit/>
+          <a:bodyPr wrap="square" rtlCol="0" anchor="ctr" lIns="91440" tIns="45720" rIns="91440" bIns="45720">
+            <a:normAutofit fontScale="100000" lnSpcReduction="0"/>
           </a:bodyPr>
           <a:lstStyle/>
           <a:p>
-            <a:pPr algn="ctr"/>
-            <a:r>
-              <a:rPr lang="en-US" sz="3779" dirty="0">
+            <a:pPr algn="ctr" marL="0" marR="0" indent="0"/>
+            <a:r>
+              <a:rPr lang="en-US" sz="2856" dirty="0" smtClean="0">
                 <a:solidFill>
                   <a:srgbClr val="FFFFFF"/>
                 </a:solidFill>
@@ -6513,14 +6513,14 @@
           </a:solidFill>
         </p:spPr>
         <p:txBody>
-          <a:bodyPr wrap="square" rtlCol="0" anchor="ctr">
-            <a:normAutofit/>
+          <a:bodyPr wrap="square" rtlCol="0" anchor="ctr" lIns="91440" tIns="45720" rIns="91440" bIns="45720">
+            <a:normAutofit fontScale="100000" lnSpcReduction="0"/>
           </a:bodyPr>
           <a:lstStyle/>
           <a:p>
-            <a:pPr algn="ctr"/>
-            <a:r>
-              <a:rPr lang="en-US" sz="2362" dirty="0">
+            <a:pPr algn="ctr" marL="0" marR="0" indent="0"/>
+            <a:r>
+              <a:rPr lang="en-US" sz="2002" dirty="0" smtClean="0">
                 <a:solidFill>
                   <a:srgbClr val="FFFFFF"/>
                 </a:solidFill>
@@ -6549,14 +6549,14 @@
           </a:solidFill>
         </p:spPr>
         <p:txBody>
-          <a:bodyPr wrap="square" rtlCol="0" anchor="ctr">
-            <a:normAutofit/>
+          <a:bodyPr wrap="square" rtlCol="0" anchor="ctr" lIns="91440" tIns="45720" rIns="91440" bIns="45720">
+            <a:normAutofit fontScale="100000" lnSpcReduction="0"/>
           </a:bodyPr>
           <a:lstStyle/>
           <a:p>
-            <a:pPr algn="ctr"/>
-            <a:r>
-              <a:rPr lang="en-US" sz="3149" dirty="0">
+            <a:pPr algn="ctr" marL="0" marR="0" indent="0"/>
+            <a:r>
+              <a:rPr lang="en-US" sz="2669" dirty="0" smtClean="0">
                 <a:solidFill>
                   <a:srgbClr val="FFFFFF"/>
                 </a:solidFill>
@@ -7403,14 +7403,14 @@
           </a:solidFill>
         </p:spPr>
         <p:txBody>
-          <a:bodyPr wrap="square" rtlCol="0" anchor="ctr">
-            <a:normAutofit/>
+          <a:bodyPr wrap="square" rtlCol="0" anchor="ctr" lIns="91440" tIns="45720" rIns="91440" bIns="45720">
+            <a:normAutofit fontScale="100000" lnSpcReduction="0"/>
           </a:bodyPr>
           <a:lstStyle/>
           <a:p>
-            <a:pPr algn="ctr"/>
-            <a:r>
-              <a:rPr lang="en-US" sz="1874" dirty="0">
+            <a:pPr algn="ctr" marL="0" marR="0" indent="0"/>
+            <a:r>
+              <a:rPr lang="en-US" sz="1737" dirty="0" smtClean="0">
                 <a:solidFill>
                   <a:srgbClr val="FFFFFF"/>
                 </a:solidFill>
@@ -7439,14 +7439,14 @@
           </a:solidFill>
         </p:spPr>
         <p:txBody>
-          <a:bodyPr wrap="square" rtlCol="0" anchor="ctr">
-            <a:normAutofit/>
+          <a:bodyPr wrap="square" rtlCol="0" anchor="ctr" lIns="91440" tIns="45720" rIns="91440" bIns="45720">
+            <a:normAutofit fontScale="100000" lnSpcReduction="0"/>
           </a:bodyPr>
           <a:lstStyle/>
           <a:p>
-            <a:pPr algn="ctr"/>
-            <a:r>
-              <a:rPr lang="en-US" sz="2460" dirty="0">
+            <a:pPr algn="ctr" marL="0" marR="0" indent="0"/>
+            <a:r>
+              <a:rPr lang="en-US" sz="2280" dirty="0" smtClean="0">
                 <a:solidFill>
                   <a:srgbClr val="000000"/>
                 </a:solidFill>
@@ -7475,14 +7475,14 @@
           </a:solidFill>
         </p:spPr>
         <p:txBody>
-          <a:bodyPr wrap="square" rtlCol="0" anchor="ctr">
-            <a:normAutofit/>
+          <a:bodyPr wrap="square" rtlCol="0" anchor="ctr" lIns="91440" tIns="45720" rIns="91440" bIns="45720">
+            <a:normAutofit fontScale="100000" lnSpcReduction="0"/>
           </a:bodyPr>
           <a:lstStyle/>
           <a:p>
-            <a:pPr algn="ctr"/>
-            <a:r>
-              <a:rPr lang="en-US" sz="2187" dirty="0">
+            <a:pPr algn="ctr" marL="0" marR="0" indent="0"/>
+            <a:r>
+              <a:rPr lang="en-US" sz="2027" dirty="0" smtClean="0">
                 <a:solidFill>
                   <a:srgbClr val="000000"/>
                 </a:solidFill>
@@ -7827,14 +7827,14 @@
           </a:solidFill>
         </p:spPr>
         <p:txBody>
-          <a:bodyPr wrap="square" rtlCol="0" anchor="ctr">
-            <a:normAutofit/>
+          <a:bodyPr wrap="square" rtlCol="0" anchor="ctr" lIns="91440" tIns="45720" rIns="91440" bIns="45720">
+            <a:normAutofit fontScale="100000" lnSpcReduction="0"/>
           </a:bodyPr>
           <a:lstStyle/>
           <a:p>
-            <a:pPr algn="ctr"/>
-            <a:r>
-              <a:rPr lang="en-US" sz="1889" dirty="0">
+            <a:pPr algn="ctr" marL="0" marR="0" indent="0"/>
+            <a:r>
+              <a:rPr lang="en-US" sz="869" dirty="0" smtClean="0">
                 <a:solidFill>
                   <a:srgbClr val="000000"/>
                 </a:solidFill>
@@ -7865,14 +7865,14 @@
           </a:ln>
         </p:spPr>
         <p:txBody>
-          <a:bodyPr wrap="square" rtlCol="0" anchor="ctr">
-            <a:normAutofit/>
+          <a:bodyPr wrap="square" rtlCol="0" anchor="ctr" lIns="91440" tIns="45720" rIns="91440" bIns="45720">
+            <a:normAutofit fontScale="100000" lnSpcReduction="0"/>
           </a:bodyPr>
           <a:lstStyle/>
           <a:p>
-            <a:pPr algn="ctr"/>
-            <a:r>
-              <a:rPr lang="en-US" sz="4049" dirty="0">
+            <a:pPr algn="ctr" marL="0" marR="0" indent="0"/>
+            <a:r>
+              <a:rPr lang="en-US" sz="3638" dirty="0" smtClean="0">
                 <a:solidFill>
                   <a:srgbClr val="000000"/>
                 </a:solidFill>
@@ -7903,14 +7903,14 @@
           </a:ln>
         </p:spPr>
         <p:txBody>
-          <a:bodyPr wrap="square" rtlCol="0" anchor="ctr">
-            <a:normAutofit/>
+          <a:bodyPr wrap="square" rtlCol="0" anchor="ctr" lIns="91440" tIns="45720" rIns="91440" bIns="45720">
+            <a:normAutofit fontScale="100000" lnSpcReduction="0"/>
           </a:bodyPr>
           <a:lstStyle/>
           <a:p>
-            <a:pPr algn="ctr"/>
-            <a:r>
-              <a:rPr lang="en-US" sz="4049" dirty="0">
+            <a:pPr algn="ctr" marL="0" marR="0" indent="0"/>
+            <a:r>
+              <a:rPr lang="en-US" sz="3638" dirty="0" smtClean="0">
                 <a:solidFill>
                   <a:srgbClr val="000000"/>
                 </a:solidFill>
@@ -7941,14 +7941,14 @@
           </a:ln>
         </p:spPr>
         <p:txBody>
-          <a:bodyPr wrap="square" rtlCol="0" anchor="ctr">
-            <a:normAutofit/>
+          <a:bodyPr wrap="square" rtlCol="0" anchor="ctr" lIns="91440" tIns="45720" rIns="91440" bIns="45720">
+            <a:normAutofit fontScale="100000" lnSpcReduction="0"/>
           </a:bodyPr>
           <a:lstStyle/>
           <a:p>
-            <a:pPr algn="ctr"/>
-            <a:r>
-              <a:rPr lang="en-US" sz="4049" dirty="0">
+            <a:pPr algn="ctr" marL="0" marR="0" indent="0"/>
+            <a:r>
+              <a:rPr lang="en-US" sz="3638" dirty="0" smtClean="0">
                 <a:solidFill>
                   <a:srgbClr val="000000"/>
                 </a:solidFill>
@@ -7979,14 +7979,14 @@
           </a:ln>
         </p:spPr>
         <p:txBody>
-          <a:bodyPr wrap="square" rtlCol="0" anchor="ctr">
-            <a:normAutofit/>
+          <a:bodyPr wrap="square" rtlCol="0" anchor="ctr" lIns="91440" tIns="45720" rIns="91440" bIns="45720">
+            <a:normAutofit fontScale="100000" lnSpcReduction="0"/>
           </a:bodyPr>
           <a:lstStyle/>
           <a:p>
-            <a:pPr algn="ctr"/>
-            <a:r>
-              <a:rPr lang="en-US" sz="4049" dirty="0">
+            <a:pPr algn="ctr" marL="0" marR="0" indent="0"/>
+            <a:r>
+              <a:rPr lang="en-US" sz="3638" dirty="0" smtClean="0">
                 <a:solidFill>
                   <a:srgbClr val="000000"/>
                 </a:solidFill>
@@ -8017,14 +8017,14 @@
           </a:ln>
         </p:spPr>
         <p:txBody>
-          <a:bodyPr wrap="square" rtlCol="0" anchor="ctr">
-            <a:normAutofit/>
+          <a:bodyPr wrap="square" rtlCol="0" anchor="ctr" lIns="91440" tIns="45720" rIns="91440" bIns="45720">
+            <a:normAutofit fontScale="100000" lnSpcReduction="0"/>
           </a:bodyPr>
           <a:lstStyle/>
           <a:p>
-            <a:pPr algn="ctr"/>
-            <a:r>
-              <a:rPr lang="en-US" sz="4049" dirty="0">
+            <a:pPr algn="ctr" marL="0" marR="0" indent="0"/>
+            <a:r>
+              <a:rPr lang="en-US" sz="3638" dirty="0" smtClean="0">
                 <a:solidFill>
                   <a:srgbClr val="000000"/>
                 </a:solidFill>
@@ -8055,14 +8055,14 @@
           </a:ln>
         </p:spPr>
         <p:txBody>
-          <a:bodyPr wrap="square" rtlCol="0" anchor="ctr">
-            <a:normAutofit/>
+          <a:bodyPr wrap="square" rtlCol="0" anchor="ctr" lIns="91440" tIns="45720" rIns="91440" bIns="45720">
+            <a:normAutofit fontScale="100000" lnSpcReduction="0"/>
           </a:bodyPr>
           <a:lstStyle/>
           <a:p>
-            <a:pPr algn="ctr"/>
-            <a:r>
-              <a:rPr lang="en-US" sz="4049" dirty="0">
+            <a:pPr algn="ctr" marL="0" marR="0" indent="0"/>
+            <a:r>
+              <a:rPr lang="en-US" sz="3638" dirty="0" smtClean="0">
                 <a:solidFill>
                   <a:srgbClr val="000000"/>
                 </a:solidFill>
@@ -8091,14 +8091,14 @@
           </a:solidFill>
         </p:spPr>
         <p:txBody>
-          <a:bodyPr wrap="square" rtlCol="0" anchor="ctr">
-            <a:normAutofit/>
+          <a:bodyPr wrap="square" rtlCol="0" anchor="ctr" lIns="91440" tIns="45720" rIns="91440" bIns="45720">
+            <a:normAutofit fontScale="100000" lnSpcReduction="0"/>
           </a:bodyPr>
           <a:lstStyle/>
           <a:p>
-            <a:pPr algn="ctr"/>
-            <a:r>
-              <a:rPr lang="en-US" sz="1889" dirty="0">
+            <a:pPr algn="ctr" marL="0" marR="0" indent="0"/>
+            <a:r>
+              <a:rPr lang="en-US" sz="724" dirty="0" smtClean="0">
                 <a:solidFill>
                   <a:srgbClr val="000000"/>
                 </a:solidFill>
@@ -8530,14 +8530,14 @@
           </a:solidFill>
         </p:spPr>
         <p:txBody>
-          <a:bodyPr wrap="square" rtlCol="0" anchor="ctr">
-            <a:normAutofit/>
+          <a:bodyPr wrap="square" rtlCol="0" anchor="ctr" lIns="91440" tIns="45720" rIns="91440" bIns="45720">
+            <a:normAutofit fontScale="100000" lnSpcReduction="0"/>
           </a:bodyPr>
           <a:lstStyle/>
           <a:p>
-            <a:pPr algn="ctr"/>
-            <a:r>
-              <a:rPr lang="en-US" sz="1259" dirty="0">
+            <a:pPr algn="ctr" marL="0" marR="0" indent="0"/>
+            <a:r>
+              <a:rPr lang="en-US" sz="1144" dirty="0" smtClean="0">
                 <a:solidFill>
                   <a:srgbClr val="FFFFFF"/>
                 </a:solidFill>
@@ -8566,14 +8566,14 @@
           </a:solidFill>
         </p:spPr>
         <p:txBody>
-          <a:bodyPr wrap="square" rtlCol="0" anchor="ctr">
-            <a:normAutofit/>
+          <a:bodyPr wrap="square" rtlCol="0" anchor="ctr" lIns="91440" tIns="45720" rIns="91440" bIns="45720">
+            <a:normAutofit fontScale="100000" lnSpcReduction="0"/>
           </a:bodyPr>
           <a:lstStyle/>
           <a:p>
-            <a:pPr algn="ctr"/>
-            <a:r>
-              <a:rPr lang="en-US" sz="1574" dirty="0">
+            <a:pPr algn="ctr" marL="0" marR="0" indent="0"/>
+            <a:r>
+              <a:rPr lang="en-US" sz="1430" dirty="0" smtClean="0">
                 <a:solidFill>
                   <a:srgbClr val="000000"/>
                 </a:solidFill>
@@ -8602,14 +8602,14 @@
           </a:solidFill>
         </p:spPr>
         <p:txBody>
-          <a:bodyPr wrap="square" rtlCol="0" anchor="ctr">
-            <a:normAutofit/>
+          <a:bodyPr wrap="square" rtlCol="0" anchor="ctr" lIns="91440" tIns="45720" rIns="91440" bIns="45720">
+            <a:normAutofit fontScale="100000" lnSpcReduction="0"/>
           </a:bodyPr>
           <a:lstStyle/>
           <a:p>
-            <a:pPr algn="ctr"/>
-            <a:r>
-              <a:rPr lang="en-US" sz="1574" dirty="0">
+            <a:pPr algn="ctr" marL="0" marR="0" indent="0"/>
+            <a:r>
+              <a:rPr lang="en-US" sz="1430" dirty="0" smtClean="0">
                 <a:solidFill>
                   <a:srgbClr val="000000"/>
                 </a:solidFill>
@@ -8638,14 +8638,14 @@
           </a:solidFill>
         </p:spPr>
         <p:txBody>
-          <a:bodyPr wrap="square" rtlCol="0" anchor="ctr">
-            <a:normAutofit/>
+          <a:bodyPr wrap="square" rtlCol="0" anchor="ctr" lIns="91440" tIns="45720" rIns="91440" bIns="45720">
+            <a:normAutofit fontScale="100000" lnSpcReduction="0"/>
           </a:bodyPr>
           <a:lstStyle/>
           <a:p>
-            <a:pPr algn="ctr"/>
-            <a:r>
-              <a:rPr lang="en-US" sz="1852" dirty="0">
+            <a:pPr algn="ctr" marL="0" marR="0" indent="0"/>
+            <a:r>
+              <a:rPr lang="en-US" sz="1486" dirty="0" smtClean="0">
                 <a:solidFill>
                   <a:srgbClr val="000000"/>
                 </a:solidFill>
@@ -9425,14 +9425,14 @@
           </a:solidFill>
         </p:spPr>
         <p:txBody>
-          <a:bodyPr wrap="square" rtlCol="0" anchor="ctr">
-            <a:normAutofit/>
+          <a:bodyPr wrap="square" rtlCol="0" anchor="ctr" lIns="91440" tIns="45720" rIns="91440" bIns="45720">
+            <a:normAutofit fontScale="100000" lnSpcReduction="0"/>
           </a:bodyPr>
           <a:lstStyle/>
           <a:p>
-            <a:pPr algn="ctr"/>
-            <a:r>
-              <a:rPr lang="en-US" sz="3499" dirty="0">
+            <a:pPr algn="ctr" marL="0" marR="0" indent="0"/>
+            <a:r>
+              <a:rPr lang="en-US" sz="3179" dirty="0" smtClean="0">
                 <a:solidFill>
                   <a:srgbClr val="FFFFFF"/>
                 </a:solidFill>
@@ -9461,14 +9461,14 @@
           </a:solidFill>
         </p:spPr>
         <p:txBody>
-          <a:bodyPr wrap="square" rtlCol="0" anchor="ctr">
-            <a:normAutofit/>
+          <a:bodyPr wrap="square" rtlCol="0" anchor="ctr" lIns="91440" tIns="45720" rIns="91440" bIns="45720">
+            <a:normAutofit fontScale="100000" lnSpcReduction="0"/>
           </a:bodyPr>
           <a:lstStyle/>
           <a:p>
-            <a:pPr algn="ctr"/>
-            <a:r>
-              <a:rPr lang="en-US" sz="4400" dirty="0">
+            <a:pPr algn="ctr" marL="0" marR="0" indent="0"/>
+            <a:r>
+              <a:rPr lang="en-US" sz="4088" dirty="0" smtClean="0">
                 <a:solidFill>
                   <a:srgbClr val="000000"/>
                 </a:solidFill>
@@ -9497,14 +9497,14 @@
           </a:solidFill>
         </p:spPr>
         <p:txBody>
-          <a:bodyPr wrap="square" rtlCol="0" anchor="ctr">
-            <a:normAutofit/>
+          <a:bodyPr wrap="square" rtlCol="0" anchor="ctr" lIns="91440" tIns="45720" rIns="91440" bIns="45720">
+            <a:normAutofit fontScale="100000" lnSpcReduction="0"/>
           </a:bodyPr>
           <a:lstStyle/>
           <a:p>
-            <a:pPr algn="ctr"/>
-            <a:r>
-              <a:rPr lang="en-US" sz="4400" dirty="0">
+            <a:pPr algn="ctr" marL="0" marR="0" indent="0"/>
+            <a:r>
+              <a:rPr lang="en-US" sz="4088" dirty="0" smtClean="0">
                 <a:solidFill>
                   <a:srgbClr val="FFFFFF"/>
                 </a:solidFill>
@@ -9533,14 +9533,14 @@
           </a:solidFill>
         </p:spPr>
         <p:txBody>
-          <a:bodyPr wrap="square" rtlCol="0" anchor="ctr">
-            <a:normAutofit/>
+          <a:bodyPr wrap="square" rtlCol="0" anchor="ctr" lIns="91440" tIns="45720" rIns="91440" bIns="45720">
+            <a:normAutofit fontScale="100000" lnSpcReduction="0"/>
           </a:bodyPr>
           <a:lstStyle/>
           <a:p>
-            <a:pPr algn="ctr"/>
-            <a:r>
-              <a:rPr lang="en-US" sz="2952" dirty="0">
+            <a:pPr algn="ctr" marL="0" marR="0" indent="0"/>
+            <a:r>
+              <a:rPr lang="en-US" sz="2592" dirty="0" smtClean="0">
                 <a:solidFill>
                   <a:srgbClr val="FFFFFF"/>
                 </a:solidFill>
@@ -9569,14 +9569,14 @@
           </a:solidFill>
         </p:spPr>
         <p:txBody>
-          <a:bodyPr wrap="square" rtlCol="0" anchor="ctr">
-            <a:normAutofit/>
+          <a:bodyPr wrap="square" rtlCol="0" anchor="ctr" lIns="91440" tIns="45720" rIns="91440" bIns="45720">
+            <a:normAutofit fontScale="100000" lnSpcReduction="0"/>
           </a:bodyPr>
           <a:lstStyle/>
           <a:p>
-            <a:pPr algn="ctr"/>
-            <a:r>
-              <a:rPr lang="en-US" sz="3374" dirty="0">
+            <a:pPr algn="ctr" marL="0" marR="0" indent="0"/>
+            <a:r>
+              <a:rPr lang="en-US" sz="2963" dirty="0" smtClean="0">
                 <a:solidFill>
                   <a:srgbClr val="000000"/>
                 </a:solidFill>

</xml_diff>

<commit_message>
feat(v0.2.11): migrate comprehensive demo to new fluent shape API with inch-based positioning
- Replace Shape::new() with prelude helpers: rect(), circle(), ellipse(), rounded_rect(), triangle(), diamond()
- Replace ShapeFill::new() with .fill(hex()) fluent method
- Replace ShapeLine::new() with .stroke(hex(), width) fluent method
- Replace .with_text() with .text() fluent method
- Migrate all EMU coordinates to inches() for readability (e.g., 500000 → inches(0.5))
- Add shapes::arrow_right() helper
</commit_message>
<xml_diff>
--- a/comprehensive_demo.pptx
+++ b/comprehensive_demo.pptx
@@ -451,8 +451,8 @@
         </p:nvSpPr>
         <p:spPr>
           <a:xfrm>
-            <a:off x="500000" y="1600000"/>
-            <a:ext cx="2500000" cy="1200000"/>
+            <a:off x="457200" y="1600200"/>
+            <a:ext cx="2468880" cy="1188720"/>
           </a:xfrm>
           <a:prstGeom prst="rect">
             <a:avLst/>
@@ -477,7 +477,7 @@
           <a:p>
             <a:pPr algn="ctr" marL="0" marR="0" indent="0"/>
             <a:r>
-              <a:rPr lang="en-US" sz="3649" dirty="0" smtClean="0">
+              <a:rPr lang="en-US" sz="3600" dirty="0" smtClean="0">
                 <a:solidFill>
                   <a:srgbClr val="000000"/>
                 </a:solidFill>
@@ -495,8 +495,8 @@
         </p:nvSpPr>
         <p:spPr>
           <a:xfrm>
-            <a:off x="3200000" y="1600000"/>
-            <a:ext cx="2500000" cy="1200000"/>
+            <a:off x="3200400" y="1600200"/>
+            <a:ext cx="2468880" cy="1188720"/>
           </a:xfrm>
           <a:prstGeom prst="rect">
             <a:avLst/>
@@ -521,7 +521,7 @@
           <a:p>
             <a:pPr algn="ctr" marL="0" marR="0" indent="0"/>
             <a:r>
-              <a:rPr lang="en-US" sz="4561" dirty="0" smtClean="0">
+              <a:rPr lang="en-US" sz="4500" dirty="0" smtClean="0">
                 <a:solidFill>
                   <a:srgbClr val="000000"/>
                 </a:solidFill>
@@ -539,8 +539,8 @@
         </p:nvSpPr>
         <p:spPr>
           <a:xfrm>
-            <a:off x="5900000" y="1600000"/>
-            <a:ext cx="2500000" cy="1200000"/>
+            <a:off x="5943600" y="1600200"/>
+            <a:ext cx="2468880" cy="1188720"/>
           </a:xfrm>
           <a:prstGeom prst="roundRect">
             <a:avLst/>
@@ -565,7 +565,7 @@
           <a:p>
             <a:pPr algn="ctr" marL="0" marR="0" indent="0"/>
             <a:r>
-              <a:rPr lang="en-US" sz="4561" dirty="0" smtClean="0">
+              <a:rPr lang="en-US" sz="4500" dirty="0" smtClean="0">
                 <a:solidFill>
                   <a:srgbClr val="000000"/>
                 </a:solidFill>
@@ -583,8 +583,8 @@
         </p:nvSpPr>
         <p:spPr>
           <a:xfrm>
-            <a:off x="1800000" y="3200000"/>
-            <a:ext cx="2500000" cy="1200000"/>
+            <a:off x="1828800" y="3200400"/>
+            <a:ext cx="2468880" cy="1188720"/>
           </a:xfrm>
           <a:prstGeom prst="ellipse">
             <a:avLst/>
@@ -612,7 +612,7 @@
           <a:p>
             <a:pPr algn="ctr" marL="0" marR="0" indent="0"/>
             <a:r>
-              <a:rPr lang="en-US" sz="5212" dirty="0" smtClean="0">
+              <a:rPr lang="en-US" sz="5142" dirty="0" smtClean="0">
                 <a:solidFill>
                   <a:srgbClr val="000000"/>
                 </a:solidFill>
@@ -630,8 +630,8 @@
         </p:nvSpPr>
         <p:spPr>
           <a:xfrm>
-            <a:off x="4800000" y="3200000"/>
-            <a:ext cx="2500000" cy="1200000"/>
+            <a:off x="4754880" y="3200400"/>
+            <a:ext cx="2468880" cy="1188720"/>
           </a:xfrm>
           <a:prstGeom prst="roundRect">
             <a:avLst/>
@@ -656,7 +656,7 @@
           <a:p>
             <a:pPr algn="ctr" marL="0" marR="0" indent="0"/>
             <a:r>
-              <a:rPr lang="en-US" sz="3649" dirty="0" smtClean="0">
+              <a:rPr lang="en-US" sz="3600" dirty="0" smtClean="0">
                 <a:solidFill>
                   <a:srgbClr val="000000"/>
                 </a:solidFill>
@@ -736,8 +736,8 @@
         </p:nvSpPr>
         <p:spPr>
           <a:xfrm>
-            <a:off x="1000000" y="1800000"/>
-            <a:ext cx="3000000" cy="2000000"/>
+            <a:off x="1005840" y="1828800"/>
+            <a:ext cx="3017520" cy="2011680"/>
           </a:xfrm>
           <a:prstGeom prst="rect">
             <a:avLst/>
@@ -754,7 +754,7 @@
           <a:p>
             <a:pPr algn="ctr" marL="0" marR="0" indent="0"/>
             <a:r>
-              <a:rPr lang="en-US" sz="4033" dirty="0" smtClean="0">
+              <a:rPr lang="en-US" sz="4058" dirty="0" smtClean="0">
                 <a:solidFill>
                   <a:srgbClr val="FFFFFF"/>
                 </a:solidFill>
@@ -772,8 +772,8 @@
         </p:nvSpPr>
         <p:spPr>
           <a:xfrm>
-            <a:off x="2000000" y="2200000"/>
-            <a:ext cx="2500000" cy="1500000"/>
+            <a:off x="2011680" y="2194560"/>
+            <a:ext cx="2468880" cy="1463040"/>
           </a:xfrm>
           <a:prstGeom prst="rect">
             <a:avLst/>
@@ -797,7 +797,7 @@
           <a:p>
             <a:pPr algn="ctr" marL="0" marR="0" indent="0"/>
             <a:r>
-              <a:rPr lang="en-US" sz="2432" dirty="0" smtClean="0">
+              <a:rPr lang="en-US" sz="2400" dirty="0" smtClean="0">
                 <a:solidFill>
                   <a:srgbClr val="FFFFFF"/>
                 </a:solidFill>
@@ -815,8 +815,8 @@
         </p:nvSpPr>
         <p:spPr>
           <a:xfrm>
-            <a:off x="4500000" y="1800000"/>
-            <a:ext cx="2500000" cy="2000000"/>
+            <a:off x="4480560" y="1828800"/>
+            <a:ext cx="2468880" cy="2011680"/>
           </a:xfrm>
           <a:prstGeom prst="ellipse">
             <a:avLst/>
@@ -840,7 +840,7 @@
           <a:p>
             <a:pPr algn="ctr" marL="0" marR="0" indent="0"/>
             <a:r>
-              <a:rPr lang="en-US" sz="2432" dirty="0" smtClean="0">
+              <a:rPr lang="en-US" sz="2400" dirty="0" smtClean="0">
                 <a:solidFill>
                   <a:srgbClr val="000000"/>
                 </a:solidFill>
@@ -858,8 +858,8 @@
         </p:nvSpPr>
         <p:spPr>
           <a:xfrm>
-            <a:off x="5500000" y="2500000"/>
-            <a:ext cx="2500000" cy="1500000"/>
+            <a:off x="5486400" y="2468880"/>
+            <a:ext cx="2468880" cy="1463040"/>
           </a:xfrm>
           <a:prstGeom prst="roundRect">
             <a:avLst/>
@@ -883,7 +883,7 @@
           <a:p>
             <a:pPr algn="ctr" marL="0" marR="0" indent="0"/>
             <a:r>
-              <a:rPr lang="en-US" sz="2432" dirty="0" smtClean="0">
+              <a:rPr lang="en-US" sz="2400" dirty="0" smtClean="0">
                 <a:solidFill>
                   <a:srgbClr val="000000"/>
                 </a:solidFill>
@@ -963,8 +963,8 @@
         </p:nvSpPr>
         <p:spPr>
           <a:xfrm>
-            <a:off x="500000" y="1800000"/>
-            <a:ext cx="1800000" cy="800000"/>
+            <a:off x="457200" y="1828800"/>
+            <a:ext cx="1828800" cy="822960"/>
           </a:xfrm>
           <a:prstGeom prst="roundRect">
             <a:avLst/>
@@ -981,7 +981,7 @@
           <a:p>
             <a:pPr algn="ctr" marL="0" marR="0" indent="0"/>
             <a:r>
-              <a:rPr lang="en-US" sz="4225" dirty="0" smtClean="0">
+              <a:rPr lang="en-US" sz="4382" dirty="0" smtClean="0">
                 <a:solidFill>
                   <a:srgbClr val="FFFFFF"/>
                 </a:solidFill>
@@ -999,8 +999,8 @@
         </p:nvSpPr>
         <p:spPr>
           <a:xfrm>
-            <a:off x="3500000" y="1800000"/>
-            <a:ext cx="1800000" cy="800000"/>
+            <a:off x="3474720" y="1828800"/>
+            <a:ext cx="1828800" cy="822960"/>
           </a:xfrm>
           <a:prstGeom prst="roundRect">
             <a:avLst/>
@@ -1017,7 +1017,7 @@
           <a:p>
             <a:pPr algn="ctr" marL="0" marR="0" indent="0"/>
             <a:r>
-              <a:rPr lang="en-US" sz="3638" dirty="0" smtClean="0">
+              <a:rPr lang="en-US" sz="3702" dirty="0" smtClean="0">
                 <a:solidFill>
                   <a:srgbClr val="FFFFFF"/>
                 </a:solidFill>
@@ -1035,8 +1035,8 @@
         </p:nvSpPr>
         <p:spPr>
           <a:xfrm>
-            <a:off x="6500000" y="1800000"/>
-            <a:ext cx="1800000" cy="800000"/>
+            <a:off x="6492240" y="1828800"/>
+            <a:ext cx="1828800" cy="822960"/>
           </a:xfrm>
           <a:prstGeom prst="roundRect">
             <a:avLst/>
@@ -1053,7 +1053,7 @@
           <a:p>
             <a:pPr algn="ctr" marL="0" marR="0" indent="0"/>
             <a:r>
-              <a:rPr lang="en-US" sz="4225" dirty="0" smtClean="0">
+              <a:rPr lang="en-US" sz="4382" dirty="0" smtClean="0">
                 <a:solidFill>
                   <a:srgbClr val="FFFFFF"/>
                 </a:solidFill>
@@ -1071,8 +1071,8 @@
         </p:nvSpPr>
         <p:spPr>
           <a:xfrm>
-            <a:off x="1000000" y="3200000"/>
-            <a:ext cx="1500000" cy="800000"/>
+            <a:off x="1005840" y="3200400"/>
+            <a:ext cx="1463040" cy="822960"/>
           </a:xfrm>
           <a:prstGeom prst="ellipse">
             <a:avLst/>
@@ -1089,7 +1089,7 @@
           <a:p>
             <a:pPr algn="ctr" marL="0" marR="0" indent="0"/>
             <a:r>
-              <a:rPr lang="en-US" sz="4225" dirty="0" smtClean="0">
+              <a:rPr lang="en-US" sz="4382" dirty="0" smtClean="0">
                 <a:solidFill>
                   <a:srgbClr val="FFFFFF"/>
                 </a:solidFill>
@@ -1107,8 +1107,8 @@
         </p:nvSpPr>
         <p:spPr>
           <a:xfrm>
-            <a:off x="4000000" y="3200000"/>
-            <a:ext cx="1500000" cy="800000"/>
+            <a:off x="4023360" y="3200400"/>
+            <a:ext cx="1463040" cy="822960"/>
           </a:xfrm>
           <a:prstGeom prst="ellipse">
             <a:avLst/>
@@ -1125,7 +1125,7 @@
           <a:p>
             <a:pPr algn="ctr" marL="0" marR="0" indent="0"/>
             <a:r>
-              <a:rPr lang="en-US" sz="4225" dirty="0" smtClean="0">
+              <a:rPr lang="en-US" sz="4382" dirty="0" smtClean="0">
                 <a:solidFill>
                   <a:srgbClr val="FFFFFF"/>
                 </a:solidFill>
@@ -1143,8 +1143,8 @@
         </p:nvSpPr>
         <p:spPr>
           <a:xfrm>
-            <a:off x="7000000" y="3200000"/>
-            <a:ext cx="1500000" cy="800000"/>
+            <a:off x="7040880" y="3200400"/>
+            <a:ext cx="1463040" cy="822960"/>
           </a:xfrm>
           <a:prstGeom prst="ellipse">
             <a:avLst/>
@@ -1161,7 +1161,7 @@
           <a:p>
             <a:pPr algn="ctr" marL="0" marR="0" indent="0"/>
             <a:r>
-              <a:rPr lang="en-US" sz="4225" dirty="0" smtClean="0">
+              <a:rPr lang="en-US" sz="4382" dirty="0" smtClean="0">
                 <a:solidFill>
                   <a:srgbClr val="000000"/>
                 </a:solidFill>
@@ -1346,8 +1346,8 @@
         </p:blipFill>
         <p:spPr>
           <a:xfrm>
-            <a:off x="500000" y="1500000"/>
-            <a:ext cx="2000000" cy="2000000"/>
+            <a:off x="457200" y="1463040"/>
+            <a:ext cx="2011680" cy="2011680"/>
           </a:xfrm>
           <a:prstGeom prst="rect">
             <a:avLst/>
@@ -1377,8 +1377,8 @@
         </p:blipFill>
         <p:spPr>
           <a:xfrm>
-            <a:off x="3200000" y="1500000"/>
-            <a:ext cx="2500000" cy="1800000"/>
+            <a:off x="3200400" y="1463040"/>
+            <a:ext cx="2468880" cy="1828800"/>
           </a:xfrm>
           <a:prstGeom prst="rect">
             <a:avLst/>
@@ -1408,8 +1408,8 @@
         </p:blipFill>
         <p:spPr>
           <a:xfrm>
-            <a:off x="6200000" y="1500000"/>
-            <a:ext cx="2300000" cy="1800000"/>
+            <a:off x="6217920" y="1463040"/>
+            <a:ext cx="2286000" cy="1828800"/>
           </a:xfrm>
           <a:prstGeom prst="rect">
             <a:avLst/>
@@ -1501,8 +1501,8 @@
         </p:blipFill>
         <p:spPr>
           <a:xfrm>
-            <a:off x="800000" y="1200000"/>
-            <a:ext cx="2200000" cy="2200000"/>
+            <a:off x="822960" y="1188720"/>
+            <a:ext cx="2194560" cy="2194560"/>
           </a:xfrm>
           <a:prstGeom prst="rect">
             <a:avLst/>
@@ -1528,8 +1528,8 @@
         </p:blipFill>
         <p:spPr>
           <a:xfrm>
-            <a:off x="3500000" y="1200000"/>
-            <a:ext cx="2800000" cy="2000000"/>
+            <a:off x="3474720" y="1188720"/>
+            <a:ext cx="2834640" cy="2011680"/>
           </a:xfrm>
           <a:prstGeom prst="rect">
             <a:avLst/>
@@ -1555,8 +1555,8 @@
         </p:blipFill>
         <p:spPr>
           <a:xfrm>
-            <a:off x="6500000" y="1200000"/>
-            <a:ext cx="2400000" cy="2000000"/>
+            <a:off x="6492240" y="1188720"/>
+            <a:ext cx="2377440" cy="2011680"/>
           </a:xfrm>
           <a:prstGeom prst="rect">
             <a:avLst/>
@@ -1645,8 +1645,8 @@
         </p:blipFill>
         <p:spPr>
           <a:xfrm>
-            <a:off x="1200000" y="1800000"/>
-            <a:ext cx="1800000" cy="1800000"/>
+            <a:off x="1188720" y="1828800"/>
+            <a:ext cx="1828800" cy="1828800"/>
           </a:xfrm>
           <a:prstGeom prst="rect">
             <a:avLst/>
@@ -1670,8 +1670,8 @@
         </p:blipFill>
         <p:spPr>
           <a:xfrm>
-            <a:off x="3500000" y="1800000"/>
-            <a:ext cx="3500000" cy="1500000"/>
+            <a:off x="3474720" y="1828800"/>
+            <a:ext cx="3474720" cy="1463040"/>
           </a:xfrm>
           <a:prstGeom prst="rect">
             <a:avLst/>
@@ -1695,8 +1695,8 @@
         </p:blipFill>
         <p:spPr>
           <a:xfrm>
-            <a:off x="7200000" y="1800000"/>
-            <a:ext cx="2000000" cy="2000000"/>
+            <a:off x="7223760" y="1828800"/>
+            <a:ext cx="2011680" cy="2011680"/>
           </a:xfrm>
           <a:prstGeom prst="rect">
             <a:avLst/>
@@ -1781,8 +1781,8 @@
         </p:blipFill>
         <p:spPr>
           <a:xfrm>
-            <a:off x="900000" y="1400000"/>
-            <a:ext cx="2200000" cy="2200000"/>
+            <a:off x="914400" y="1371600"/>
+            <a:ext cx="2194560" cy="2194560"/>
           </a:xfrm>
           <a:prstGeom prst="rect">
             <a:avLst/>
@@ -1812,8 +1812,8 @@
         </p:blipFill>
         <p:spPr>
           <a:xfrm>
-            <a:off x="3600000" y="1400000"/>
-            <a:ext cx="2600000" cy="1900000"/>
+            <a:off x="3657600" y="1371600"/>
+            <a:ext cx="2651760" cy="1920240"/>
           </a:xfrm>
           <a:prstGeom prst="rect">
             <a:avLst/>
@@ -1843,8 +1843,8 @@
         </p:blipFill>
         <p:spPr>
           <a:xfrm>
-            <a:off x="6600000" y="1400000"/>
-            <a:ext cx="2300000" cy="1900000"/>
+            <a:off x="6583680" y="1371600"/>
+            <a:ext cx="2286000" cy="1920240"/>
           </a:xfrm>
           <a:prstGeom prst="rect">
             <a:avLst/>
@@ -1936,8 +1936,8 @@
         </p:blipFill>
         <p:spPr>
           <a:xfrm>
-            <a:off x="900000" y="1400000"/>
-            <a:ext cx="2200000" cy="2200000"/>
+            <a:off x="914400" y="1371600"/>
+            <a:ext cx="2194560" cy="2194560"/>
           </a:xfrm>
           <a:prstGeom prst="rect">
             <a:avLst/>
@@ -1963,8 +1963,8 @@
         </p:blipFill>
         <p:spPr>
           <a:xfrm>
-            <a:off x="3600000" y="1400000"/>
-            <a:ext cx="2600000" cy="1900000"/>
+            <a:off x="3657600" y="1371600"/>
+            <a:ext cx="2651760" cy="1920240"/>
           </a:xfrm>
           <a:prstGeom prst="rect">
             <a:avLst/>
@@ -1990,8 +1990,8 @@
         </p:blipFill>
         <p:spPr>
           <a:xfrm>
-            <a:off x="6600000" y="1400000"/>
-            <a:ext cx="2300000" cy="1900000"/>
+            <a:off x="6583680" y="1371600"/>
+            <a:ext cx="2286000" cy="1920240"/>
           </a:xfrm>
           <a:prstGeom prst="rect">
             <a:avLst/>
@@ -2079,8 +2079,8 @@
         </p:blipFill>
         <p:spPr>
           <a:xfrm>
-            <a:off x="900000" y="1400000"/>
-            <a:ext cx="2200000" cy="2200000"/>
+            <a:off x="914400" y="1371600"/>
+            <a:ext cx="2194560" cy="2194560"/>
           </a:xfrm>
           <a:prstGeom prst="rect">
             <a:avLst/>
@@ -2110,8 +2110,8 @@
         </p:blipFill>
         <p:spPr>
           <a:xfrm>
-            <a:off x="3600000" y="1400000"/>
-            <a:ext cx="2600000" cy="1900000"/>
+            <a:off x="3657600" y="1371600"/>
+            <a:ext cx="2651760" cy="1920240"/>
           </a:xfrm>
           <a:prstGeom prst="rect">
             <a:avLst/>
@@ -2141,8 +2141,8 @@
         </p:blipFill>
         <p:spPr>
           <a:xfrm>
-            <a:off x="6600000" y="1400000"/>
-            <a:ext cx="2300000" cy="1900000"/>
+            <a:off x="6583680" y="1371600"/>
+            <a:ext cx="2286000" cy="1920240"/>
           </a:xfrm>
           <a:prstGeom prst="rect">
             <a:avLst/>
@@ -2234,8 +2234,8 @@
         </p:blipFill>
         <p:spPr>
           <a:xfrm>
-            <a:off x="900000" y="1400000"/>
-            <a:ext cx="2200000" cy="2200000"/>
+            <a:off x="914400" y="1371600"/>
+            <a:ext cx="2194560" cy="2194560"/>
           </a:xfrm>
           <a:prstGeom prst="rect">
             <a:avLst/>
@@ -2261,8 +2261,8 @@
         </p:blipFill>
         <p:spPr>
           <a:xfrm>
-            <a:off x="3600000" y="1400000"/>
-            <a:ext cx="2600000" cy="1900000"/>
+            <a:off x="3657600" y="1371600"/>
+            <a:ext cx="2651760" cy="1920240"/>
           </a:xfrm>
           <a:prstGeom prst="rect">
             <a:avLst/>
@@ -2288,8 +2288,8 @@
         </p:blipFill>
         <p:spPr>
           <a:xfrm>
-            <a:off x="6600000" y="1400000"/>
-            <a:ext cx="2300000" cy="1900000"/>
+            <a:off x="6583680" y="1371600"/>
+            <a:ext cx="2286000" cy="1920240"/>
           </a:xfrm>
           <a:prstGeom prst="rect">
             <a:avLst/>
@@ -2439,8 +2439,8 @@
         </p:blipFill>
         <p:spPr>
           <a:xfrm>
-            <a:off x="900000" y="1400000"/>
-            <a:ext cx="2200000" cy="2200000"/>
+            <a:off x="914400" y="1371600"/>
+            <a:ext cx="2194560" cy="2194560"/>
           </a:xfrm>
           <a:prstGeom prst="rect">
             <a:avLst/>
@@ -2471,8 +2471,8 @@
         </p:blipFill>
         <p:spPr>
           <a:xfrm>
-            <a:off x="3600000" y="1400000"/>
-            <a:ext cx="2600000" cy="1900000"/>
+            <a:off x="3657600" y="1371600"/>
+            <a:ext cx="2651760" cy="1920240"/>
           </a:xfrm>
           <a:prstGeom prst="rect">
             <a:avLst/>
@@ -2503,8 +2503,8 @@
         </p:blipFill>
         <p:spPr>
           <a:xfrm>
-            <a:off x="6600000" y="1400000"/>
-            <a:ext cx="2300000" cy="1900000"/>
+            <a:off x="6583680" y="1371600"/>
+            <a:ext cx="2286000" cy="1920240"/>
           </a:xfrm>
           <a:prstGeom prst="rect">
             <a:avLst/>
@@ -3599,8 +3599,8 @@
         </p:nvSpPr>
         <p:spPr>
           <a:xfrm>
-            <a:off x="300000" y="2000000"/>
-            <a:ext cx="1400000" cy="800000"/>
+            <a:off x="274320" y="2011680"/>
+            <a:ext cx="1371600" cy="822960"/>
           </a:xfrm>
           <a:prstGeom prst="roundRect">
             <a:avLst/>
@@ -3617,7 +3617,7 @@
           <a:p>
             <a:pPr algn="ctr" marL="0" marR="0" indent="0"/>
             <a:r>
-              <a:rPr lang="en-US" sz="1742" dirty="0" smtClean="0">
+              <a:rPr lang="en-US" sz="1701" dirty="0" smtClean="0">
                 <a:solidFill>
                   <a:srgbClr val="FFFFFF"/>
                 </a:solidFill>
@@ -3635,8 +3635,8 @@
         </p:nvSpPr>
         <p:spPr>
           <a:xfrm>
-            <a:off x="1800000" y="2200000"/>
-            <a:ext cx="400000" cy="400000"/>
+            <a:off x="1828800" y="2194560"/>
+            <a:ext cx="365760" cy="365760"/>
           </a:xfrm>
           <a:prstGeom prst="rightArrow">
             <a:avLst/>
@@ -3659,8 +3659,8 @@
         </p:nvSpPr>
         <p:spPr>
           <a:xfrm>
-            <a:off x="2300000" y="2000000"/>
-            <a:ext cx="1400000" cy="800000"/>
+            <a:off x="2286000" y="2011680"/>
+            <a:ext cx="1371600" cy="822960"/>
           </a:xfrm>
           <a:prstGeom prst="roundRect">
             <a:avLst/>
@@ -3677,7 +3677,7 @@
           <a:p>
             <a:pPr algn="ctr" marL="0" marR="0" indent="0"/>
             <a:r>
-              <a:rPr lang="en-US" sz="2129" dirty="0" smtClean="0">
+              <a:rPr lang="en-US" sz="2079" dirty="0" smtClean="0">
                 <a:solidFill>
                   <a:srgbClr val="000000"/>
                 </a:solidFill>
@@ -3695,8 +3695,8 @@
         </p:nvSpPr>
         <p:spPr>
           <a:xfrm>
-            <a:off x="3800000" y="2200000"/>
-            <a:ext cx="400000" cy="400000"/>
+            <a:off x="3840480" y="2194560"/>
+            <a:ext cx="365760" cy="365760"/>
           </a:xfrm>
           <a:prstGeom prst="rightArrow">
             <a:avLst/>
@@ -3719,8 +3719,8 @@
         </p:nvSpPr>
         <p:spPr>
           <a:xfrm>
-            <a:off x="4300000" y="2000000"/>
-            <a:ext cx="1400000" cy="800000"/>
+            <a:off x="4297680" y="2011680"/>
+            <a:ext cx="1371600" cy="822960"/>
           </a:xfrm>
           <a:prstGeom prst="roundRect">
             <a:avLst/>
@@ -3737,7 +3737,7 @@
           <a:p>
             <a:pPr algn="ctr" marL="0" marR="0" indent="0"/>
             <a:r>
-              <a:rPr lang="en-US" sz="1916" dirty="0" smtClean="0">
+              <a:rPr lang="en-US" sz="1872" dirty="0" smtClean="0">
                 <a:solidFill>
                   <a:srgbClr val="000000"/>
                 </a:solidFill>
@@ -3755,8 +3755,8 @@
         </p:nvSpPr>
         <p:spPr>
           <a:xfrm>
-            <a:off x="5800000" y="2200000"/>
-            <a:ext cx="400000" cy="400000"/>
+            <a:off x="5760720" y="2194560"/>
+            <a:ext cx="365760" cy="365760"/>
           </a:xfrm>
           <a:prstGeom prst="rightArrow">
             <a:avLst/>
@@ -3779,8 +3779,8 @@
         </p:nvSpPr>
         <p:spPr>
           <a:xfrm>
-            <a:off x="6300000" y="2000000"/>
-            <a:ext cx="1400000" cy="800000"/>
+            <a:off x="6309360" y="2011680"/>
+            <a:ext cx="1371600" cy="822960"/>
           </a:xfrm>
           <a:prstGeom prst="roundRect">
             <a:avLst/>
@@ -3797,7 +3797,7 @@
           <a:p>
             <a:pPr algn="ctr" marL="0" marR="0" indent="0"/>
             <a:r>
-              <a:rPr lang="en-US" sz="2129" dirty="0" smtClean="0">
+              <a:rPr lang="en-US" sz="2079" dirty="0" smtClean="0">
                 <a:solidFill>
                   <a:srgbClr val="000000"/>
                 </a:solidFill>
@@ -3877,8 +3877,8 @@
         </p:nvSpPr>
         <p:spPr>
           <a:xfrm>
-            <a:off x="3500000" y="1400000"/>
-            <a:ext cx="2000000" cy="600000"/>
+            <a:off x="3474720" y="1371600"/>
+            <a:ext cx="2011680" cy="640080"/>
           </a:xfrm>
           <a:prstGeom prst="roundRect">
             <a:avLst/>
@@ -3895,7 +3895,7 @@
           <a:p>
             <a:pPr algn="ctr" marL="0" marR="0" indent="0"/>
             <a:r>
-              <a:rPr lang="en-US" sz="2856" dirty="0" smtClean="0">
+              <a:rPr lang="en-US" sz="3130" dirty="0" smtClean="0">
                 <a:solidFill>
                   <a:srgbClr val="FFFFFF"/>
                 </a:solidFill>
@@ -3913,8 +3913,8 @@
         </p:nvSpPr>
         <p:spPr>
           <a:xfrm>
-            <a:off x="4450000" y="2000000"/>
-            <a:ext cx="100000" cy="400000"/>
+            <a:off x="4480560" y="2011680"/>
+            <a:ext cx="91440" cy="365760"/>
           </a:xfrm>
           <a:prstGeom prst="rect">
             <a:avLst/>
@@ -3937,8 +3937,8 @@
         </p:nvSpPr>
         <p:spPr>
           <a:xfrm>
-            <a:off x="1950000" y="2400000"/>
-            <a:ext cx="5100000" cy="50000"/>
+            <a:off x="1920240" y="2377440"/>
+            <a:ext cx="5120640" cy="45720"/>
           </a:xfrm>
           <a:prstGeom prst="rect">
             <a:avLst/>
@@ -3961,8 +3961,8 @@
         </p:nvSpPr>
         <p:spPr>
           <a:xfrm>
-            <a:off x="1000000" y="2600000"/>
-            <a:ext cx="1800000" cy="500000"/>
+            <a:off x="1005840" y="2560320"/>
+            <a:ext cx="1828800" cy="457200"/>
           </a:xfrm>
           <a:prstGeom prst="roundRect">
             <a:avLst/>
@@ -3979,7 +3979,7 @@
           <a:p>
             <a:pPr algn="ctr" marL="0" marR="0" indent="0"/>
             <a:r>
-              <a:rPr lang="en-US" sz="2171" dirty="0" smtClean="0">
+              <a:rPr lang="en-US" sz="1878" dirty="0" smtClean="0">
                 <a:solidFill>
                   <a:srgbClr val="FFFFFF"/>
                 </a:solidFill>
@@ -3997,8 +3997,8 @@
         </p:nvSpPr>
         <p:spPr>
           <a:xfrm>
-            <a:off x="3600000" y="2600000"/>
-            <a:ext cx="1800000" cy="500000"/>
+            <a:off x="3566160" y="2560320"/>
+            <a:ext cx="1828800" cy="457200"/>
           </a:xfrm>
           <a:prstGeom prst="roundRect">
             <a:avLst/>
@@ -4015,7 +4015,7 @@
           <a:p>
             <a:pPr algn="ctr" marL="0" marR="0" indent="0"/>
             <a:r>
-              <a:rPr lang="en-US" sz="2171" dirty="0" smtClean="0">
+              <a:rPr lang="en-US" sz="1878" dirty="0" smtClean="0">
                 <a:solidFill>
                   <a:srgbClr val="FFFFFF"/>
                 </a:solidFill>
@@ -4033,8 +4033,8 @@
         </p:nvSpPr>
         <p:spPr>
           <a:xfrm>
-            <a:off x="6200000" y="2600000"/>
-            <a:ext cx="1800000" cy="500000"/>
+            <a:off x="6217920" y="2560320"/>
+            <a:ext cx="1828800" cy="457200"/>
           </a:xfrm>
           <a:prstGeom prst="roundRect">
             <a:avLst/>
@@ -4051,7 +4051,7 @@
           <a:p>
             <a:pPr algn="ctr" marL="0" marR="0" indent="0"/>
             <a:r>
-              <a:rPr lang="en-US" sz="2171" dirty="0" smtClean="0">
+              <a:rPr lang="en-US" sz="1878" dirty="0" smtClean="0">
                 <a:solidFill>
                   <a:srgbClr val="FFFFFF"/>
                 </a:solidFill>
@@ -4069,8 +4069,8 @@
         </p:nvSpPr>
         <p:spPr>
           <a:xfrm>
-            <a:off x="1850000" y="2450000"/>
-            <a:ext cx="50000" cy="150000"/>
+            <a:off x="1828800" y="2468880"/>
+            <a:ext cx="45720" cy="146304"/>
           </a:xfrm>
           <a:prstGeom prst="rect">
             <a:avLst/>
@@ -4093,8 +4093,8 @@
         </p:nvSpPr>
         <p:spPr>
           <a:xfrm>
-            <a:off x="4450000" y="2450000"/>
-            <a:ext cx="50000" cy="150000"/>
+            <a:off x="4480560" y="2468880"/>
+            <a:ext cx="45720" cy="146304"/>
           </a:xfrm>
           <a:prstGeom prst="rect">
             <a:avLst/>
@@ -4117,8 +4117,8 @@
         </p:nvSpPr>
         <p:spPr>
           <a:xfrm>
-            <a:off x="7050000" y="2450000"/>
-            <a:ext cx="50000" cy="150000"/>
+            <a:off x="7040880" y="2468880"/>
+            <a:ext cx="45720" cy="146304"/>
           </a:xfrm>
           <a:prstGeom prst="rect">
             <a:avLst/>
@@ -4141,8 +4141,8 @@
         </p:nvSpPr>
         <p:spPr>
           <a:xfrm>
-            <a:off x="500000" y="3300000"/>
-            <a:ext cx="1200000" cy="400000"/>
+            <a:off x="457200" y="3291840"/>
+            <a:ext cx="1188720" cy="365760"/>
           </a:xfrm>
           <a:prstGeom prst="rect">
             <a:avLst/>
@@ -4159,7 +4159,7 @@
           <a:p>
             <a:pPr algn="ctr" marL="0" marR="0" indent="0"/>
             <a:r>
-              <a:rPr lang="en-US" sz="1456" dirty="0" smtClean="0">
+              <a:rPr lang="en-US" sz="1252" dirty="0" smtClean="0">
                 <a:solidFill>
                   <a:srgbClr val="000000"/>
                 </a:solidFill>
@@ -4177,8 +4177,8 @@
         </p:nvSpPr>
         <p:spPr>
           <a:xfrm>
-            <a:off x="1800000" y="3300000"/>
-            <a:ext cx="1200000" cy="400000"/>
+            <a:off x="1828800" y="3291840"/>
+            <a:ext cx="1188720" cy="365760"/>
           </a:xfrm>
           <a:prstGeom prst="rect">
             <a:avLst/>
@@ -4195,7 +4195,7 @@
           <a:p>
             <a:pPr algn="ctr" marL="0" marR="0" indent="0"/>
             <a:r>
-              <a:rPr lang="en-US" sz="1486" dirty="0" smtClean="0">
+              <a:rPr lang="en-US" sz="1252" dirty="0" smtClean="0">
                 <a:solidFill>
                   <a:srgbClr val="000000"/>
                 </a:solidFill>
@@ -4275,8 +4275,8 @@
         </p:nvSpPr>
         <p:spPr>
           <a:xfrm>
-            <a:off x="1500000" y="1600000"/>
-            <a:ext cx="2500000" cy="1500000"/>
+            <a:off x="1463040" y="1600200"/>
+            <a:ext cx="2468880" cy="1463040"/>
           </a:xfrm>
           <a:prstGeom prst="roundRect">
             <a:avLst/>
@@ -4293,7 +4293,7 @@
           <a:p>
             <a:pPr algn="l" marL="0" marR="0" indent="0"/>
             <a:r>
-              <a:rPr lang="en-US" sz="2254" dirty="0" smtClean="0">
+              <a:rPr lang="en-US" sz="2191" dirty="0" smtClean="0">
                 <a:solidFill>
                   <a:srgbClr val="FFFFFF"/>
                 </a:solidFill>
@@ -4313,8 +4313,8 @@
         </p:nvSpPr>
         <p:spPr>
           <a:xfrm>
-            <a:off x="4500000" y="1600000"/>
-            <a:ext cx="2500000" cy="1500000"/>
+            <a:off x="4480560" y="1600200"/>
+            <a:ext cx="2468880" cy="1463040"/>
           </a:xfrm>
           <a:prstGeom prst="roundRect">
             <a:avLst/>
@@ -4331,7 +4331,7 @@
           <a:p>
             <a:pPr algn="l" marL="0" marR="0" indent="0"/>
             <a:r>
-              <a:rPr lang="en-US" sz="2254" dirty="0" smtClean="0">
+              <a:rPr lang="en-US" sz="2191" dirty="0" smtClean="0">
                 <a:solidFill>
                   <a:srgbClr val="000000"/>
                 </a:solidFill>
@@ -4351,8 +4351,8 @@
         </p:nvSpPr>
         <p:spPr>
           <a:xfrm>
-            <a:off x="4500000" y="3300000"/>
-            <a:ext cx="2500000" cy="1500000"/>
+            <a:off x="4480560" y="3291840"/>
+            <a:ext cx="2468880" cy="1463040"/>
           </a:xfrm>
           <a:prstGeom prst="roundRect">
             <a:avLst/>
@@ -4369,7 +4369,7 @@
           <a:p>
             <a:pPr algn="l" marL="0" marR="0" indent="0"/>
             <a:r>
-              <a:rPr lang="en-US" sz="2254" dirty="0" smtClean="0">
+              <a:rPr lang="en-US" sz="2191" dirty="0" smtClean="0">
                 <a:solidFill>
                   <a:srgbClr val="000000"/>
                 </a:solidFill>
@@ -4389,8 +4389,8 @@
         </p:nvSpPr>
         <p:spPr>
           <a:xfrm>
-            <a:off x="1500000" y="3300000"/>
-            <a:ext cx="2500000" cy="1500000"/>
+            <a:off x="1463040" y="3291840"/>
+            <a:ext cx="2468880" cy="1463040"/>
           </a:xfrm>
           <a:prstGeom prst="roundRect">
             <a:avLst/>
@@ -4407,7 +4407,7 @@
           <a:p>
             <a:pPr algn="l" marL="0" marR="0" indent="0"/>
             <a:r>
-              <a:rPr lang="en-US" sz="2254" dirty="0" smtClean="0">
+              <a:rPr lang="en-US" sz="2191" dirty="0" smtClean="0">
                 <a:solidFill>
                   <a:srgbClr val="000000"/>
                 </a:solidFill>
@@ -4427,8 +4427,8 @@
         </p:nvSpPr>
         <p:spPr>
           <a:xfrm>
-            <a:off x="4100000" y="2100000"/>
-            <a:ext cx="300000" cy="300000"/>
+            <a:off x="4114800" y="2103120"/>
+            <a:ext cx="274320" cy="274320"/>
           </a:xfrm>
           <a:prstGeom prst="rightArrow">
             <a:avLst/>
@@ -4451,8 +4451,8 @@
         </p:nvSpPr>
         <p:spPr>
           <a:xfrm>
-            <a:off x="5600000" y="3200000"/>
-            <a:ext cx="300000" cy="200000"/>
+            <a:off x="5577840" y="3200400"/>
+            <a:ext cx="274320" cy="182880"/>
           </a:xfrm>
           <a:prstGeom prst="downArrow">
             <a:avLst/>
@@ -4475,8 +4475,8 @@
         </p:nvSpPr>
         <p:spPr>
           <a:xfrm>
-            <a:off x="4100000" y="3800000"/>
-            <a:ext cx="300000" cy="300000"/>
+            <a:off x="4114800" y="3840480"/>
+            <a:ext cx="274320" cy="274320"/>
           </a:xfrm>
           <a:prstGeom prst="leftArrow">
             <a:avLst/>
@@ -4499,8 +4499,8 @@
         </p:nvSpPr>
         <p:spPr>
           <a:xfrm>
-            <a:off x="2600000" y="3200000"/>
-            <a:ext cx="300000" cy="200000"/>
+            <a:off x="2560320" y="3200400"/>
+            <a:ext cx="274320" cy="182880"/>
           </a:xfrm>
           <a:prstGeom prst="upArrow">
             <a:avLst/>
@@ -4585,8 +4585,8 @@
         </p:nvSpPr>
         <p:spPr>
           <a:xfrm>
-            <a:off x="500000" y="4000000"/>
-            <a:ext cx="8000000" cy="600000"/>
+            <a:off x="457200" y="4023360"/>
+            <a:ext cx="7955279" cy="640080"/>
           </a:xfrm>
           <a:prstGeom prst="trapezoid">
             <a:avLst/>
@@ -4603,7 +4603,7 @@
           <a:p>
             <a:pPr algn="ctr" marL="0" marR="0" indent="0"/>
             <a:r>
-              <a:rPr lang="en-US" sz="2380" dirty="0" smtClean="0">
+              <a:rPr lang="en-US" sz="2608" dirty="0" smtClean="0">
                 <a:solidFill>
                   <a:srgbClr val="FFFFFF"/>
                 </a:solidFill>
@@ -4621,8 +4621,8 @@
         </p:nvSpPr>
         <p:spPr>
           <a:xfrm>
-            <a:off x="1000000" y="3400000"/>
-            <a:ext cx="7000000" cy="600000"/>
+            <a:off x="1005840" y="3383280"/>
+            <a:ext cx="7040880" cy="640080"/>
           </a:xfrm>
           <a:prstGeom prst="trapezoid">
             <a:avLst/>
@@ -4639,7 +4639,7 @@
           <a:p>
             <a:pPr algn="ctr" marL="0" marR="0" indent="0"/>
             <a:r>
-              <a:rPr lang="en-US" sz="2380" dirty="0" smtClean="0">
+              <a:rPr lang="en-US" sz="2608" dirty="0" smtClean="0">
                 <a:solidFill>
                   <a:srgbClr val="000000"/>
                 </a:solidFill>
@@ -4657,8 +4657,8 @@
         </p:nvSpPr>
         <p:spPr>
           <a:xfrm>
-            <a:off x="1500000" y="2800000"/>
-            <a:ext cx="6000000" cy="600000"/>
+            <a:off x="1463040" y="2834640"/>
+            <a:ext cx="6035040" cy="640080"/>
           </a:xfrm>
           <a:prstGeom prst="trapezoid">
             <a:avLst/>
@@ -4675,7 +4675,7 @@
           <a:p>
             <a:pPr algn="ctr" marL="0" marR="0" indent="0"/>
             <a:r>
-              <a:rPr lang="en-US" sz="2380" dirty="0" smtClean="0">
+              <a:rPr lang="en-US" sz="2608" dirty="0" smtClean="0">
                 <a:solidFill>
                   <a:srgbClr val="000000"/>
                 </a:solidFill>
@@ -4693,8 +4693,8 @@
         </p:nvSpPr>
         <p:spPr>
           <a:xfrm>
-            <a:off x="2000000" y="2200000"/>
-            <a:ext cx="5000000" cy="600000"/>
+            <a:off x="2011680" y="2194560"/>
+            <a:ext cx="5029200" cy="640080"/>
           </a:xfrm>
           <a:prstGeom prst="trapezoid">
             <a:avLst/>
@@ -4711,7 +4711,7 @@
           <a:p>
             <a:pPr algn="ctr" marL="0" marR="0" indent="0"/>
             <a:r>
-              <a:rPr lang="en-US" sz="2615" dirty="0" smtClean="0">
+              <a:rPr lang="en-US" sz="2631" dirty="0" smtClean="0">
                 <a:solidFill>
                   <a:srgbClr val="000000"/>
                 </a:solidFill>
@@ -4729,8 +4729,8 @@
         </p:nvSpPr>
         <p:spPr>
           <a:xfrm>
-            <a:off x="2500000" y="1500000"/>
-            <a:ext cx="4000000" cy="700000"/>
+            <a:off x="2468880" y="1463040"/>
+            <a:ext cx="4023360" cy="731520"/>
           </a:xfrm>
           <a:prstGeom prst="triangle">
             <a:avLst/>
@@ -4747,7 +4747,7 @@
           <a:p>
             <a:pPr algn="ctr" marL="0" marR="0" indent="0"/>
             <a:r>
-              <a:rPr lang="en-US" sz="3339" dirty="0" smtClean="0">
+              <a:rPr lang="en-US" sz="3360" dirty="0" smtClean="0">
                 <a:solidFill>
                   <a:srgbClr val="FFFFFF"/>
                 </a:solidFill>
@@ -4827,8 +4827,8 @@
         </p:nvSpPr>
         <p:spPr>
           <a:xfrm>
-            <a:off x="1500000" y="1800000"/>
-            <a:ext cx="3000000" cy="3000000"/>
+            <a:off x="1463040" y="1828800"/>
+            <a:ext cx="3017520" cy="3017520"/>
           </a:xfrm>
           <a:prstGeom prst="ellipse">
             <a:avLst/>
@@ -4863,8 +4863,8 @@
         </p:nvSpPr>
         <p:spPr>
           <a:xfrm>
-            <a:off x="3500000" y="1800000"/>
-            <a:ext cx="3000000" cy="3000000"/>
+            <a:off x="3474720" y="1828800"/>
+            <a:ext cx="3017520" cy="3017520"/>
           </a:xfrm>
           <a:prstGeom prst="ellipse">
             <a:avLst/>
@@ -4881,7 +4881,7 @@
           <a:p>
             <a:pPr algn="ctr" marL="0" marR="0" indent="0"/>
             <a:r>
-              <a:rPr lang="en-US" sz="6337" dirty="0" smtClean="0">
+              <a:rPr lang="en-US" sz="6377" dirty="0" smtClean="0">
                 <a:solidFill>
                   <a:srgbClr val="000000"/>
                 </a:solidFill>
@@ -4899,8 +4899,8 @@
         </p:nvSpPr>
         <p:spPr>
           <a:xfrm>
-            <a:off x="2500000" y="3200000"/>
-            <a:ext cx="3000000" cy="3000000"/>
+            <a:off x="2468880" y="3200400"/>
+            <a:ext cx="3017520" cy="3017520"/>
           </a:xfrm>
           <a:prstGeom prst="ellipse">
             <a:avLst/>
@@ -4917,7 +4917,7 @@
           <a:p>
             <a:pPr algn="ctr" marL="0" marR="0" indent="0"/>
             <a:r>
-              <a:rPr lang="en-US" sz="4033" dirty="0" smtClean="0">
+              <a:rPr lang="en-US" sz="4058" dirty="0" smtClean="0">
                 <a:solidFill>
                   <a:srgbClr val="000000"/>
                 </a:solidFill>
@@ -4935,8 +4935,8 @@
         </p:nvSpPr>
         <p:spPr>
           <a:xfrm>
-            <a:off x="3200000" y="2800000"/>
-            <a:ext cx="1600000" cy="800000"/>
+            <a:off x="3200400" y="2834640"/>
+            <a:ext cx="1600200" cy="822960"/>
           </a:xfrm>
           <a:prstGeom prst="ellipse">
             <a:avLst/>
@@ -6929,8 +6929,8 @@
         </p:nvSpPr>
         <p:spPr>
           <a:xfrm>
-            <a:off x="500000" y="1600000"/>
-            <a:ext cx="1800000" cy="800000"/>
+            <a:off x="457200" y="1600200"/>
+            <a:ext cx="1828800" cy="822960"/>
           </a:xfrm>
           <a:prstGeom prst="rect">
             <a:avLst/>
@@ -6947,7 +6947,7 @@
           <a:p>
             <a:pPr algn="ctr" marL="0" marR="0" indent="0"/>
             <a:r>
-              <a:rPr lang="en-US" sz="2829" dirty="0" smtClean="0">
+              <a:rPr lang="en-US" sz="2879" dirty="0" smtClean="0">
                 <a:solidFill>
                   <a:srgbClr val="FFFFFF"/>
                 </a:solidFill>
@@ -6965,8 +6965,8 @@
         </p:nvSpPr>
         <p:spPr>
           <a:xfrm>
-            <a:off x="2500000" y="1600000"/>
-            <a:ext cx="1800000" cy="800000"/>
+            <a:off x="2468880" y="1600200"/>
+            <a:ext cx="1828800" cy="822960"/>
           </a:xfrm>
           <a:prstGeom prst="rect">
             <a:avLst/>
@@ -6983,7 +6983,7 @@
           <a:p>
             <a:pPr algn="ctr" marL="0" marR="0" indent="0"/>
             <a:r>
-              <a:rPr lang="en-US" sz="4225" dirty="0" smtClean="0">
+              <a:rPr lang="en-US" sz="4320" dirty="0" smtClean="0">
                 <a:solidFill>
                   <a:srgbClr val="FFFFFF"/>
                 </a:solidFill>
@@ -7001,8 +7001,8 @@
         </p:nvSpPr>
         <p:spPr>
           <a:xfrm>
-            <a:off x="4500000" y="1600000"/>
-            <a:ext cx="1800000" cy="800000"/>
+            <a:off x="4480560" y="1600200"/>
+            <a:ext cx="1828800" cy="822960"/>
           </a:xfrm>
           <a:prstGeom prst="rect">
             <a:avLst/>
@@ -7019,7 +7019,7 @@
           <a:p>
             <a:pPr algn="ctr" marL="0" marR="0" indent="0"/>
             <a:r>
-              <a:rPr lang="en-US" sz="3638" dirty="0" smtClean="0">
+              <a:rPr lang="en-US" sz="3702" dirty="0" smtClean="0">
                 <a:solidFill>
                   <a:srgbClr val="FFFFFF"/>
                 </a:solidFill>
@@ -7037,8 +7037,8 @@
         </p:nvSpPr>
         <p:spPr>
           <a:xfrm>
-            <a:off x="6500000" y="1600000"/>
-            <a:ext cx="1800000" cy="800000"/>
+            <a:off x="6492240" y="1600200"/>
+            <a:ext cx="1828800" cy="822960"/>
           </a:xfrm>
           <a:prstGeom prst="rect">
             <a:avLst/>
@@ -7055,7 +7055,7 @@
           <a:p>
             <a:pPr algn="ctr" marL="0" marR="0" indent="0"/>
             <a:r>
-              <a:rPr lang="en-US" sz="4225" dirty="0" smtClean="0">
+              <a:rPr lang="en-US" sz="4382" dirty="0" smtClean="0">
                 <a:solidFill>
                   <a:srgbClr val="000000"/>
                 </a:solidFill>
@@ -7073,8 +7073,8 @@
         </p:nvSpPr>
         <p:spPr>
           <a:xfrm>
-            <a:off x="500000" y="2700000"/>
-            <a:ext cx="1800000" cy="800000"/>
+            <a:off x="457200" y="2743200"/>
+            <a:ext cx="1828800" cy="822960"/>
           </a:xfrm>
           <a:prstGeom prst="rect">
             <a:avLst/>
@@ -7091,7 +7091,7 @@
           <a:p>
             <a:pPr algn="ctr" marL="0" marR="0" indent="0"/>
             <a:r>
-              <a:rPr lang="en-US" sz="4225" dirty="0" smtClean="0">
+              <a:rPr lang="en-US" sz="4320" dirty="0" smtClean="0">
                 <a:solidFill>
                   <a:srgbClr val="FFFFFF"/>
                 </a:solidFill>
@@ -7109,8 +7109,8 @@
         </p:nvSpPr>
         <p:spPr>
           <a:xfrm>
-            <a:off x="2500000" y="2700000"/>
-            <a:ext cx="1800000" cy="800000"/>
+            <a:off x="2468880" y="2743200"/>
+            <a:ext cx="1828800" cy="822960"/>
           </a:xfrm>
           <a:prstGeom prst="rect">
             <a:avLst/>
@@ -7127,7 +7127,7 @@
           <a:p>
             <a:pPr algn="ctr" marL="0" marR="0" indent="0"/>
             <a:r>
-              <a:rPr lang="en-US" sz="4225" dirty="0" smtClean="0">
+              <a:rPr lang="en-US" sz="4382" dirty="0" smtClean="0">
                 <a:solidFill>
                   <a:srgbClr val="FFFFFF"/>
                 </a:solidFill>
@@ -7145,8 +7145,8 @@
         </p:nvSpPr>
         <p:spPr>
           <a:xfrm>
-            <a:off x="4500000" y="2700000"/>
-            <a:ext cx="1800000" cy="800000"/>
+            <a:off x="4480560" y="2743200"/>
+            <a:ext cx="1828800" cy="822960"/>
           </a:xfrm>
           <a:prstGeom prst="rect">
             <a:avLst/>
@@ -7163,7 +7163,7 @@
           <a:p>
             <a:pPr algn="ctr" marL="0" marR="0" indent="0"/>
             <a:r>
-              <a:rPr lang="en-US" sz="4225" dirty="0" smtClean="0">
+              <a:rPr lang="en-US" sz="4320" dirty="0" smtClean="0">
                 <a:solidFill>
                   <a:srgbClr val="FFFFFF"/>
                 </a:solidFill>
@@ -7243,8 +7243,8 @@
         </p:nvSpPr>
         <p:spPr>
           <a:xfrm>
-            <a:off x="500000" y="1600000"/>
-            <a:ext cx="1200000" cy="600000"/>
+            <a:off x="457200" y="1600200"/>
+            <a:ext cx="1188720" cy="640080"/>
           </a:xfrm>
           <a:prstGeom prst="rect">
             <a:avLst/>
@@ -7261,7 +7261,7 @@
           <a:p>
             <a:pPr algn="ctr" marL="0" marR="0" indent="0"/>
             <a:r>
-              <a:rPr lang="en-US" sz="2856" dirty="0" smtClean="0">
+              <a:rPr lang="en-US" sz="3130" dirty="0" smtClean="0">
                 <a:solidFill>
                   <a:srgbClr val="FFFFFF"/>
                 </a:solidFill>
@@ -7279,8 +7279,8 @@
         </p:nvSpPr>
         <p:spPr>
           <a:xfrm>
-            <a:off x="1900000" y="1600000"/>
-            <a:ext cx="1200000" cy="600000"/>
+            <a:off x="1920240" y="1600200"/>
+            <a:ext cx="1188720" cy="640080"/>
           </a:xfrm>
           <a:prstGeom prst="rect">
             <a:avLst/>
@@ -7297,7 +7297,7 @@
           <a:p>
             <a:pPr algn="ctr" marL="0" marR="0" indent="0"/>
             <a:r>
-              <a:rPr lang="en-US" sz="2669" dirty="0" smtClean="0">
+              <a:rPr lang="en-US" sz="2640" dirty="0" smtClean="0">
                 <a:solidFill>
                   <a:srgbClr val="FFFFFF"/>
                 </a:solidFill>
@@ -7315,8 +7315,8 @@
         </p:nvSpPr>
         <p:spPr>
           <a:xfrm>
-            <a:off x="3300000" y="1600000"/>
-            <a:ext cx="1200000" cy="600000"/>
+            <a:off x="3291840" y="1600200"/>
+            <a:ext cx="1188720" cy="640080"/>
           </a:xfrm>
           <a:prstGeom prst="rect">
             <a:avLst/>
@@ -7333,7 +7333,7 @@
           <a:p>
             <a:pPr algn="ctr" marL="0" marR="0" indent="0"/>
             <a:r>
-              <a:rPr lang="en-US" sz="2288" dirty="0" smtClean="0">
+              <a:rPr lang="en-US" sz="2262" dirty="0" smtClean="0">
                 <a:solidFill>
                   <a:srgbClr val="000000"/>
                 </a:solidFill>
@@ -7351,8 +7351,8 @@
         </p:nvSpPr>
         <p:spPr>
           <a:xfrm>
-            <a:off x="4700000" y="1600000"/>
-            <a:ext cx="1200000" cy="600000"/>
+            <a:off x="4663440" y="1600200"/>
+            <a:ext cx="1188720" cy="640080"/>
           </a:xfrm>
           <a:prstGeom prst="rect">
             <a:avLst/>
@@ -7369,7 +7369,7 @@
           <a:p>
             <a:pPr algn="ctr" marL="0" marR="0" indent="0"/>
             <a:r>
-              <a:rPr lang="en-US" sz="2002" dirty="0" smtClean="0">
+              <a:rPr lang="en-US" sz="1980" dirty="0" smtClean="0">
                 <a:solidFill>
                   <a:srgbClr val="000000"/>
                 </a:solidFill>
@@ -7387,8 +7387,8 @@
         </p:nvSpPr>
         <p:spPr>
           <a:xfrm>
-            <a:off x="6100000" y="1600000"/>
-            <a:ext cx="1200000" cy="600000"/>
+            <a:off x="6126480" y="1600200"/>
+            <a:ext cx="1188720" cy="640080"/>
           </a:xfrm>
           <a:prstGeom prst="rect">
             <a:avLst/>
@@ -7405,7 +7405,7 @@
           <a:p>
             <a:pPr algn="ctr" marL="0" marR="0" indent="0"/>
             <a:r>
-              <a:rPr lang="en-US" sz="2002" dirty="0" smtClean="0">
+              <a:rPr lang="en-US" sz="1980" dirty="0" smtClean="0">
                 <a:solidFill>
                   <a:srgbClr val="FFFFFF"/>
                 </a:solidFill>
@@ -7423,8 +7423,8 @@
         </p:nvSpPr>
         <p:spPr>
           <a:xfrm>
-            <a:off x="500000" y="2500000"/>
-            <a:ext cx="1200000" cy="600000"/>
+            <a:off x="457200" y="2468880"/>
+            <a:ext cx="1188720" cy="640080"/>
           </a:xfrm>
           <a:prstGeom prst="rect">
             <a:avLst/>
@@ -7441,7 +7441,7 @@
           <a:p>
             <a:pPr algn="ctr" marL="0" marR="0" indent="0"/>
             <a:r>
-              <a:rPr lang="en-US" sz="2669" dirty="0" smtClean="0">
+              <a:rPr lang="en-US" sz="2640" dirty="0" smtClean="0">
                 <a:solidFill>
                   <a:srgbClr val="FFFFFF"/>
                 </a:solidFill>
@@ -7459,8 +7459,8 @@
         </p:nvSpPr>
         <p:spPr>
           <a:xfrm>
-            <a:off x="1900000" y="2500000"/>
-            <a:ext cx="1200000" cy="600000"/>
+            <a:off x="1920240" y="2468880"/>
+            <a:ext cx="1188720" cy="640080"/>
           </a:xfrm>
           <a:prstGeom prst="rect">
             <a:avLst/>
@@ -7477,7 +7477,7 @@
           <a:p>
             <a:pPr algn="ctr" marL="0" marR="0" indent="0"/>
             <a:r>
-              <a:rPr lang="en-US" sz="2288" dirty="0" smtClean="0">
+              <a:rPr lang="en-US" sz="2262" dirty="0" smtClean="0">
                 <a:solidFill>
                   <a:srgbClr val="FFFFFF"/>
                 </a:solidFill>
@@ -7495,8 +7495,8 @@
         </p:nvSpPr>
         <p:spPr>
           <a:xfrm>
-            <a:off x="3300000" y="2500000"/>
-            <a:ext cx="1200000" cy="600000"/>
+            <a:off x="3291840" y="2468880"/>
+            <a:ext cx="1188720" cy="640080"/>
           </a:xfrm>
           <a:prstGeom prst="rect">
             <a:avLst/>
@@ -7513,7 +7513,7 @@
           <a:p>
             <a:pPr algn="ctr" marL="0" marR="0" indent="0"/>
             <a:r>
-              <a:rPr lang="en-US" sz="2856" dirty="0" smtClean="0">
+              <a:rPr lang="en-US" sz="3130" dirty="0" smtClean="0">
                 <a:solidFill>
                   <a:srgbClr val="FFFFFF"/>
                 </a:solidFill>
@@ -7531,8 +7531,8 @@
         </p:nvSpPr>
         <p:spPr>
           <a:xfrm>
-            <a:off x="4700000" y="2500000"/>
-            <a:ext cx="1200000" cy="600000"/>
+            <a:off x="4663440" y="2468880"/>
+            <a:ext cx="1188720" cy="640080"/>
           </a:xfrm>
           <a:prstGeom prst="rect">
             <a:avLst/>
@@ -7549,7 +7549,7 @@
           <a:p>
             <a:pPr algn="ctr" marL="0" marR="0" indent="0"/>
             <a:r>
-              <a:rPr lang="en-US" sz="2002" dirty="0" smtClean="0">
+              <a:rPr lang="en-US" sz="1980" dirty="0" smtClean="0">
                 <a:solidFill>
                   <a:srgbClr val="FFFFFF"/>
                 </a:solidFill>
@@ -7567,8 +7567,8 @@
         </p:nvSpPr>
         <p:spPr>
           <a:xfrm>
-            <a:off x="6100000" y="2500000"/>
-            <a:ext cx="1200000" cy="600000"/>
+            <a:off x="6126480" y="2468880"/>
+            <a:ext cx="1188720" cy="640080"/>
           </a:xfrm>
           <a:prstGeom prst="rect">
             <a:avLst/>
@@ -7585,7 +7585,7 @@
           <a:p>
             <a:pPr algn="ctr" marL="0" marR="0" indent="0"/>
             <a:r>
-              <a:rPr lang="en-US" sz="2669" dirty="0" smtClean="0">
+              <a:rPr lang="en-US" sz="2640" dirty="0" smtClean="0">
                 <a:solidFill>
                   <a:srgbClr val="FFFFFF"/>
                 </a:solidFill>
@@ -8531,8 +8531,8 @@
         </p:nvSpPr>
         <p:spPr>
           <a:xfrm>
-            <a:off x="300000" y="4200000"/>
-            <a:ext cx="2500000" cy="600000"/>
+            <a:off x="274320" y="4206240"/>
+            <a:ext cx="2468880" cy="640080"/>
           </a:xfrm>
           <a:prstGeom prst="roundRect">
             <a:avLst/>
@@ -8549,7 +8549,7 @@
           <a:p>
             <a:pPr algn="ctr" marL="0" marR="0" indent="0"/>
             <a:r>
-              <a:rPr lang="en-US" sz="1737" dirty="0" smtClean="0">
+              <a:rPr lang="en-US" sz="1714" dirty="0" smtClean="0">
                 <a:solidFill>
                   <a:srgbClr val="FFFFFF"/>
                 </a:solidFill>
@@ -8567,8 +8567,8 @@
         </p:nvSpPr>
         <p:spPr>
           <a:xfrm>
-            <a:off x="3100000" y="4200000"/>
-            <a:ext cx="2500000" cy="600000"/>
+            <a:off x="3108960" y="4206240"/>
+            <a:ext cx="2468880" cy="640080"/>
           </a:xfrm>
           <a:prstGeom prst="roundRect">
             <a:avLst/>
@@ -8585,7 +8585,7 @@
           <a:p>
             <a:pPr algn="ctr" marL="0" marR="0" indent="0"/>
             <a:r>
-              <a:rPr lang="en-US" sz="2280" dirty="0" smtClean="0">
+              <a:rPr lang="en-US" sz="2250" dirty="0" smtClean="0">
                 <a:solidFill>
                   <a:srgbClr val="000000"/>
                 </a:solidFill>
@@ -8603,8 +8603,8 @@
         </p:nvSpPr>
         <p:spPr>
           <a:xfrm>
-            <a:off x="5900000" y="4200000"/>
-            <a:ext cx="2500000" cy="600000"/>
+            <a:off x="5943600" y="4206240"/>
+            <a:ext cx="2468880" cy="640080"/>
           </a:xfrm>
           <a:prstGeom prst="roundRect">
             <a:avLst/>
@@ -8621,7 +8621,7 @@
           <a:p>
             <a:pPr algn="ctr" marL="0" marR="0" indent="0"/>
             <a:r>
-              <a:rPr lang="en-US" sz="2027" dirty="0" smtClean="0">
+              <a:rPr lang="en-US" sz="2000" dirty="0" smtClean="0">
                 <a:solidFill>
                   <a:srgbClr val="000000"/>
                 </a:solidFill>
@@ -8955,8 +8955,8 @@
         </p:nvSpPr>
         <p:spPr>
           <a:xfrm>
-            <a:off x="300000" y="1500000"/>
-            <a:ext cx="4200000" cy="300000"/>
+            <a:off x="274320" y="1463040"/>
+            <a:ext cx="4206240" cy="274320"/>
           </a:xfrm>
           <a:prstGeom prst="rect">
             <a:avLst/>
@@ -8991,8 +8991,8 @@
         </p:nvSpPr>
         <p:spPr>
           <a:xfrm>
-            <a:off x="400000" y="2000000"/>
-            <a:ext cx="1800000" cy="1100000"/>
+            <a:off x="365760" y="2011680"/>
+            <a:ext cx="1828800" cy="1097280"/>
           </a:xfrm>
           <a:prstGeom prst="rect">
             <a:avLst/>
@@ -9011,7 +9011,7 @@
           <a:p>
             <a:pPr algn="ctr" marL="0" marR="0" indent="0"/>
             <a:r>
-              <a:rPr lang="en-US" sz="3638" dirty="0" smtClean="0">
+              <a:rPr lang="en-US" sz="3702" dirty="0" smtClean="0">
                 <a:solidFill>
                   <a:srgbClr val="000000"/>
                 </a:solidFill>
@@ -9029,8 +9029,8 @@
         </p:nvSpPr>
         <p:spPr>
           <a:xfrm>
-            <a:off x="2500000" y="2000000"/>
-            <a:ext cx="1800000" cy="1100000"/>
+            <a:off x="2468880" y="2011680"/>
+            <a:ext cx="1828800" cy="1097280"/>
           </a:xfrm>
           <a:prstGeom prst="rect">
             <a:avLst/>
@@ -9049,7 +9049,7 @@
           <a:p>
             <a:pPr algn="ctr" marL="0" marR="0" indent="0"/>
             <a:r>
-              <a:rPr lang="en-US" sz="3638" dirty="0" smtClean="0">
+              <a:rPr lang="en-US" sz="3702" dirty="0" smtClean="0">
                 <a:solidFill>
                   <a:srgbClr val="000000"/>
                 </a:solidFill>
@@ -9067,8 +9067,8 @@
         </p:nvSpPr>
         <p:spPr>
           <a:xfrm>
-            <a:off x="400000" y="3200000"/>
-            <a:ext cx="1800000" cy="1100000"/>
+            <a:off x="365760" y="3200400"/>
+            <a:ext cx="1828800" cy="1097280"/>
           </a:xfrm>
           <a:prstGeom prst="rect">
             <a:avLst/>
@@ -9087,7 +9087,7 @@
           <a:p>
             <a:pPr algn="ctr" marL="0" marR="0" indent="0"/>
             <a:r>
-              <a:rPr lang="en-US" sz="3638" dirty="0" smtClean="0">
+              <a:rPr lang="en-US" sz="3702" dirty="0" smtClean="0">
                 <a:solidFill>
                   <a:srgbClr val="000000"/>
                 </a:solidFill>
@@ -9105,8 +9105,8 @@
         </p:nvSpPr>
         <p:spPr>
           <a:xfrm>
-            <a:off x="2500000" y="3200000"/>
-            <a:ext cx="1800000" cy="1100000"/>
+            <a:off x="2468880" y="3200400"/>
+            <a:ext cx="1828800" cy="1097280"/>
           </a:xfrm>
           <a:prstGeom prst="rect">
             <a:avLst/>
@@ -9125,7 +9125,7 @@
           <a:p>
             <a:pPr algn="ctr" marL="0" marR="0" indent="0"/>
             <a:r>
-              <a:rPr lang="en-US" sz="3638" dirty="0" smtClean="0">
+              <a:rPr lang="en-US" sz="3702" dirty="0" smtClean="0">
                 <a:solidFill>
                   <a:srgbClr val="000000"/>
                 </a:solidFill>
@@ -9143,8 +9143,8 @@
         </p:nvSpPr>
         <p:spPr>
           <a:xfrm>
-            <a:off x="400000" y="4400000"/>
-            <a:ext cx="1800000" cy="1100000"/>
+            <a:off x="365760" y="4389120"/>
+            <a:ext cx="1828800" cy="1097280"/>
           </a:xfrm>
           <a:prstGeom prst="rect">
             <a:avLst/>
@@ -9163,7 +9163,7 @@
           <a:p>
             <a:pPr algn="ctr" marL="0" marR="0" indent="0"/>
             <a:r>
-              <a:rPr lang="en-US" sz="3638" dirty="0" smtClean="0">
+              <a:rPr lang="en-US" sz="3702" dirty="0" smtClean="0">
                 <a:solidFill>
                   <a:srgbClr val="000000"/>
                 </a:solidFill>
@@ -9181,8 +9181,8 @@
         </p:nvSpPr>
         <p:spPr>
           <a:xfrm>
-            <a:off x="2500000" y="4400000"/>
-            <a:ext cx="1800000" cy="1100000"/>
+            <a:off x="2468880" y="4389120"/>
+            <a:ext cx="1828800" cy="1097280"/>
           </a:xfrm>
           <a:prstGeom prst="rect">
             <a:avLst/>
@@ -9201,7 +9201,7 @@
           <a:p>
             <a:pPr algn="ctr" marL="0" marR="0" indent="0"/>
             <a:r>
-              <a:rPr lang="en-US" sz="3638" dirty="0" smtClean="0">
+              <a:rPr lang="en-US" sz="3702" dirty="0" smtClean="0">
                 <a:solidFill>
                   <a:srgbClr val="000000"/>
                 </a:solidFill>
@@ -9219,8 +9219,8 @@
         </p:nvSpPr>
         <p:spPr>
           <a:xfrm>
-            <a:off x="300000" y="5600000"/>
-            <a:ext cx="4200000" cy="300000"/>
+            <a:off x="274320" y="5577840"/>
+            <a:ext cx="4206240" cy="274320"/>
           </a:xfrm>
           <a:prstGeom prst="rect">
             <a:avLst/>
@@ -9658,8 +9658,8 @@
         </p:nvSpPr>
         <p:spPr>
           <a:xfrm>
-            <a:off x="300000" y="4400000"/>
-            <a:ext cx="2000000" cy="400000"/>
+            <a:off x="274320" y="4389120"/>
+            <a:ext cx="2011680" cy="365760"/>
           </a:xfrm>
           <a:prstGeom prst="roundRect">
             <a:avLst/>
@@ -9676,7 +9676,7 @@
           <a:p>
             <a:pPr algn="ctr" marL="0" marR="0" indent="0"/>
             <a:r>
-              <a:rPr lang="en-US" sz="1144" dirty="0" smtClean="0">
+              <a:rPr lang="en-US" sz="1152" dirty="0" smtClean="0">
                 <a:solidFill>
                   <a:srgbClr val="FFFFFF"/>
                 </a:solidFill>
@@ -9694,8 +9694,8 @@
         </p:nvSpPr>
         <p:spPr>
           <a:xfrm>
-            <a:off x="2500000" y="4400000"/>
-            <a:ext cx="2000000" cy="400000"/>
+            <a:off x="2468880" y="4389120"/>
+            <a:ext cx="2011680" cy="365760"/>
           </a:xfrm>
           <a:prstGeom prst="roundRect">
             <a:avLst/>
@@ -9712,7 +9712,7 @@
           <a:p>
             <a:pPr algn="ctr" marL="0" marR="0" indent="0"/>
             <a:r>
-              <a:rPr lang="en-US" sz="1430" dirty="0" smtClean="0">
+              <a:rPr lang="en-US" sz="1252" dirty="0" smtClean="0">
                 <a:solidFill>
                   <a:srgbClr val="000000"/>
                 </a:solidFill>
@@ -9730,8 +9730,8 @@
         </p:nvSpPr>
         <p:spPr>
           <a:xfrm>
-            <a:off x="4700000" y="4400000"/>
-            <a:ext cx="2000000" cy="400000"/>
+            <a:off x="4663440" y="4389120"/>
+            <a:ext cx="2011680" cy="365760"/>
           </a:xfrm>
           <a:prstGeom prst="roundRect">
             <a:avLst/>
@@ -9748,7 +9748,7 @@
           <a:p>
             <a:pPr algn="ctr" marL="0" marR="0" indent="0"/>
             <a:r>
-              <a:rPr lang="en-US" sz="1430" dirty="0" smtClean="0">
+              <a:rPr lang="en-US" sz="1252" dirty="0" smtClean="0">
                 <a:solidFill>
                   <a:srgbClr val="000000"/>
                 </a:solidFill>
@@ -9766,8 +9766,8 @@
         </p:nvSpPr>
         <p:spPr>
           <a:xfrm>
-            <a:off x="6900000" y="4400000"/>
-            <a:ext cx="2000000" cy="400000"/>
+            <a:off x="6858000" y="4389120"/>
+            <a:ext cx="2011680" cy="365760"/>
           </a:xfrm>
           <a:prstGeom prst="roundRect">
             <a:avLst/>
@@ -9784,7 +9784,7 @@
           <a:p>
             <a:pPr algn="ctr" marL="0" marR="0" indent="0"/>
             <a:r>
-              <a:rPr lang="en-US" sz="1486" dirty="0" smtClean="0">
+              <a:rPr lang="en-US" sz="1252" dirty="0" smtClean="0">
                 <a:solidFill>
                   <a:srgbClr val="000000"/>
                 </a:solidFill>
@@ -10443,8 +10443,8 @@
         </p:nvSpPr>
         <p:spPr>
           <a:xfrm>
-            <a:off x="500000" y="1600000"/>
-            <a:ext cx="2000000" cy="1000000"/>
+            <a:off x="457200" y="1600200"/>
+            <a:ext cx="2011680" cy="1005840"/>
           </a:xfrm>
           <a:prstGeom prst="rect">
             <a:avLst/>
@@ -10461,7 +10461,7 @@
           <a:p>
             <a:pPr algn="ctr" marL="0" marR="0" indent="0"/>
             <a:r>
-              <a:rPr lang="en-US" sz="3179" dirty="0" smtClean="0">
+              <a:rPr lang="en-US" sz="3200" dirty="0" smtClean="0">
                 <a:solidFill>
                   <a:srgbClr val="FFFFFF"/>
                 </a:solidFill>
@@ -10479,8 +10479,8 @@
         </p:nvSpPr>
         <p:spPr>
           <a:xfrm>
-            <a:off x="3000000" y="1600000"/>
-            <a:ext cx="2000000" cy="1000000"/>
+            <a:off x="3017520" y="1600200"/>
+            <a:ext cx="2011680" cy="1005840"/>
           </a:xfrm>
           <a:prstGeom prst="ellipse">
             <a:avLst/>
@@ -10497,7 +10497,7 @@
           <a:p>
             <a:pPr algn="ctr" marL="0" marR="0" indent="0"/>
             <a:r>
-              <a:rPr lang="en-US" sz="4088" dirty="0" smtClean="0">
+              <a:rPr lang="en-US" sz="4114" dirty="0" smtClean="0">
                 <a:solidFill>
                   <a:srgbClr val="000000"/>
                 </a:solidFill>
@@ -10515,8 +10515,8 @@
         </p:nvSpPr>
         <p:spPr>
           <a:xfrm>
-            <a:off x="5500000" y="1600000"/>
-            <a:ext cx="2000000" cy="1000000"/>
+            <a:off x="5486400" y="1600200"/>
+            <a:ext cx="2011680" cy="1005840"/>
           </a:xfrm>
           <a:prstGeom prst="roundRect">
             <a:avLst/>
@@ -10533,7 +10533,7 @@
           <a:p>
             <a:pPr algn="ctr" marL="0" marR="0" indent="0"/>
             <a:r>
-              <a:rPr lang="en-US" sz="4088" dirty="0" smtClean="0">
+              <a:rPr lang="en-US" sz="4114" dirty="0" smtClean="0">
                 <a:solidFill>
                   <a:srgbClr val="FFFFFF"/>
                 </a:solidFill>
@@ -10551,8 +10551,8 @@
         </p:nvSpPr>
         <p:spPr>
           <a:xfrm>
-            <a:off x="1500000" y="3000000"/>
-            <a:ext cx="1500000" cy="1200000"/>
+            <a:off x="1463040" y="3017520"/>
+            <a:ext cx="1463040" cy="1188720"/>
           </a:xfrm>
           <a:prstGeom prst="triangle">
             <a:avLst/>
@@ -10569,7 +10569,7 @@
           <a:p>
             <a:pPr algn="ctr" marL="0" marR="0" indent="0"/>
             <a:r>
-              <a:rPr lang="en-US" sz="2592" dirty="0" smtClean="0">
+              <a:rPr lang="en-US" sz="2520" dirty="0" smtClean="0">
                 <a:solidFill>
                   <a:srgbClr val="FFFFFF"/>
                 </a:solidFill>
@@ -10587,8 +10587,8 @@
         </p:nvSpPr>
         <p:spPr>
           <a:xfrm>
-            <a:off x="4000000" y="3000000"/>
-            <a:ext cx="1500000" cy="1200000"/>
+            <a:off x="4023360" y="3017520"/>
+            <a:ext cx="1463040" cy="1188720"/>
           </a:xfrm>
           <a:prstGeom prst="diamond">
             <a:avLst/>
@@ -10605,7 +10605,7 @@
           <a:p>
             <a:pPr algn="ctr" marL="0" marR="0" indent="0"/>
             <a:r>
-              <a:rPr lang="en-US" sz="2963" dirty="0" smtClean="0">
+              <a:rPr lang="en-US" sz="2880" dirty="0" smtClean="0">
                 <a:solidFill>
                   <a:srgbClr val="000000"/>
                 </a:solidFill>

</xml_diff>

<commit_message>
feat(v0.2.11): add color aliases and table helpers to simplified API
- Add ColorValue struct with 40+ color aliases (red(), blue(), material_blue(), etc.)
- Add color adjustments: .lighter(), .darker(), .opacity(), .transparent(), .mix()
- Add QuickTable builder with fluent API: .header(), .row(), .at(), .build()
- Add table helpers: simple_table(), table_with_header(), cell(), header_cell()
- Add extension methods: .fill(), .stroke(), .text() (shorter than .with_fill(), etc.)
- Export color and
</commit_message>
<xml_diff>
--- a/comprehensive_demo.pptx
+++ b/comprehensive_demo.pptx
@@ -779,9 +779,7 @@
             <a:avLst/>
           </a:prstGeom>
           <a:solidFill>
-            <a:srgbClr val="F44336">
-              <a:alpha val="75000"/>
-            </a:srgbClr>
+            <a:srgbClr val="F44336"/>
           </a:solidFill>
           <a:ln w="25400">
             <a:solidFill>
@@ -822,9 +820,7 @@
             <a:avLst/>
           </a:prstGeom>
           <a:solidFill>
-            <a:srgbClr val="4CAF50">
-              <a:alpha val="50000"/>
-            </a:srgbClr>
+            <a:srgbClr val="4CAF50"/>
           </a:solidFill>
           <a:ln w="25400">
             <a:solidFill>
@@ -865,9 +861,7 @@
             <a:avLst/>
           </a:prstGeom>
           <a:solidFill>
-            <a:srgbClr val="FF9800">
-              <a:alpha val="25000"/>
-            </a:srgbClr>
+            <a:srgbClr val="FF9800"/>
           </a:solidFill>
           <a:ln w="25400">
             <a:solidFill>

</xml_diff>

<commit_message>
chore(v0.2.16): enhance theme customization and update documentation
- Introduce `PresentationTheme` for advanced theme customization, allowing custom colors and fonts in generated PPTX files.
- Update `ARCHITECTURE.md` to reflect new theme features and file structure changes.
- Revise `README.md` to include examples of using embedded themes and customization options.
- Bump version to 0.2.16 in relevant files and update `TODO.md` to reflect completed tasks.
- Update `SPEC.md` to document the significance of theme enhancements as a milestone.
</commit_message>
<xml_diff>
--- a/comprehensive_demo.pptx
+++ b/comprehensive_demo.pptx
@@ -2598,7 +2598,7 @@
               <a:tr h="400000">
                 <a:tc>
                   <a:txBody>
-                    <a:bodyPr/>
+                    <a:bodyPr wrap="square"/>
                     <a:lstStyle/>
                     <a:p>
                       <a:r>
@@ -2619,7 +2619,7 @@
                 </a:tc>
                 <a:tc>
                   <a:txBody>
-                    <a:bodyPr/>
+                    <a:bodyPr wrap="square"/>
                     <a:lstStyle/>
                     <a:p>
                       <a:r>
@@ -2636,7 +2636,7 @@
                 </a:tc>
                 <a:tc>
                   <a:txBody>
-                    <a:bodyPr/>
+                    <a:bodyPr wrap="square"/>
                     <a:lstStyle/>
                     <a:p>
                       <a:r>
@@ -2653,7 +2653,7 @@
                 </a:tc>
                 <a:tc>
                   <a:txBody>
-                    <a:bodyPr/>
+                    <a:bodyPr wrap="square"/>
                     <a:lstStyle/>
                     <a:p>
                       <a:r>
@@ -2672,7 +2672,7 @@
               <a:tr h="400000">
                 <a:tc>
                   <a:txBody>
-                    <a:bodyPr/>
+                    <a:bodyPr wrap="square"/>
                     <a:lstStyle/>
                     <a:p>
                       <a:r>
@@ -2693,7 +2693,7 @@
                 </a:tc>
                 <a:tc>
                   <a:txBody>
-                    <a:bodyPr/>
+                    <a:bodyPr wrap="square"/>
                     <a:lstStyle/>
                     <a:p>
                       <a:r>
@@ -2714,7 +2714,7 @@
                 </a:tc>
                 <a:tc>
                   <a:txBody>
-                    <a:bodyPr/>
+                    <a:bodyPr wrap="square"/>
                     <a:lstStyle/>
                     <a:p>
                       <a:r>
@@ -2735,7 +2735,7 @@
                 </a:tc>
                 <a:tc>
                   <a:txBody>
-                    <a:bodyPr/>
+                    <a:bodyPr wrap="square"/>
                     <a:lstStyle/>
                     <a:p>
                       <a:r>
@@ -2758,9 +2758,9 @@
               <a:tr h="400000">
                 <a:tc>
                   <a:txBody>
-                    <a:bodyPr/>
-                    <a:lstStyle/>
-                    <a:p>
+                    <a:bodyPr wrap="square"/>
+                    <a:lstStyle/>
+                    <a:p algn="l">
                       <a:r>
                         <a:rPr lang="en-US" dirty="0">
                           <a:solidFill>
@@ -2775,9 +2775,9 @@
                 </a:tc>
                 <a:tc>
                   <a:txBody>
-                    <a:bodyPr/>
-                    <a:lstStyle/>
-                    <a:p>
+                    <a:bodyPr wrap="square"/>
+                    <a:lstStyle/>
+                    <a:p algn="r">
                       <a:r>
                         <a:rPr lang="en-US" dirty="0">
                           <a:solidFill>
@@ -2792,9 +2792,9 @@
                 </a:tc>
                 <a:tc>
                   <a:txBody>
-                    <a:bodyPr/>
-                    <a:lstStyle/>
-                    <a:p>
+                    <a:bodyPr wrap="square"/>
+                    <a:lstStyle/>
+                    <a:p algn="r">
                       <a:r>
                         <a:rPr lang="en-US" dirty="0">
                           <a:solidFill>
@@ -2809,9 +2809,9 @@
                 </a:tc>
                 <a:tc>
                   <a:txBody>
-                    <a:bodyPr/>
-                    <a:lstStyle/>
-                    <a:p>
+                    <a:bodyPr wrap="square"/>
+                    <a:lstStyle/>
+                    <a:p algn="r">
                       <a:r>
                         <a:rPr lang="en-US" dirty="0" b="1">
                           <a:solidFill>
@@ -2828,9 +2828,9 @@
               <a:tr h="400000">
                 <a:tc>
                   <a:txBody>
-                    <a:bodyPr/>
-                    <a:lstStyle/>
-                    <a:p>
+                    <a:bodyPr wrap="square"/>
+                    <a:lstStyle/>
+                    <a:p algn="l">
                       <a:r>
                         <a:rPr lang="en-US" dirty="0">
                           <a:solidFill>
@@ -2845,9 +2845,9 @@
                 </a:tc>
                 <a:tc>
                   <a:txBody>
-                    <a:bodyPr/>
-                    <a:lstStyle/>
-                    <a:p>
+                    <a:bodyPr wrap="square"/>
+                    <a:lstStyle/>
+                    <a:p algn="r">
                       <a:r>
                         <a:rPr lang="en-US" dirty="0">
                           <a:solidFill>
@@ -2862,9 +2862,9 @@
                 </a:tc>
                 <a:tc>
                   <a:txBody>
-                    <a:bodyPr/>
-                    <a:lstStyle/>
-                    <a:p>
+                    <a:bodyPr wrap="square"/>
+                    <a:lstStyle/>
+                    <a:p algn="r">
                       <a:r>
                         <a:rPr lang="en-US" dirty="0">
                           <a:solidFill>
@@ -2879,9 +2879,9 @@
                 </a:tc>
                 <a:tc>
                   <a:txBody>
-                    <a:bodyPr/>
-                    <a:lstStyle/>
-                    <a:p>
+                    <a:bodyPr wrap="square"/>
+                    <a:lstStyle/>
+                    <a:p algn="r">
                       <a:r>
                         <a:rPr lang="en-US" dirty="0" b="1">
                           <a:solidFill>
@@ -2898,9 +2898,9 @@
               <a:tr h="400000">
                 <a:tc>
                   <a:txBody>
-                    <a:bodyPr/>
-                    <a:lstStyle/>
-                    <a:p>
+                    <a:bodyPr wrap="square"/>
+                    <a:lstStyle/>
+                    <a:p algn="l">
                       <a:r>
                         <a:rPr lang="en-US" dirty="0" b="1">
                           <a:solidFill>
@@ -2919,9 +2919,9 @@
                 </a:tc>
                 <a:tc>
                   <a:txBody>
-                    <a:bodyPr/>
-                    <a:lstStyle/>
-                    <a:p>
+                    <a:bodyPr wrap="square"/>
+                    <a:lstStyle/>
+                    <a:p algn="r">
                       <a:r>
                         <a:rPr lang="en-US" dirty="0" b="1">
                           <a:solidFill>
@@ -2940,9 +2940,9 @@
                 </a:tc>
                 <a:tc>
                   <a:txBody>
-                    <a:bodyPr/>
-                    <a:lstStyle/>
-                    <a:p>
+                    <a:bodyPr wrap="square"/>
+                    <a:lstStyle/>
+                    <a:p algn="r">
                       <a:r>
                         <a:rPr lang="en-US" dirty="0" b="1">
                           <a:solidFill>
@@ -2961,9 +2961,9 @@
                 </a:tc>
                 <a:tc>
                   <a:txBody>
-                    <a:bodyPr/>
-                    <a:lstStyle/>
-                    <a:p>
+                    <a:bodyPr wrap="square"/>
+                    <a:lstStyle/>
+                    <a:p algn="r">
                       <a:r>
                         <a:rPr lang="en-US" dirty="0" b="1">
                           <a:solidFill>
@@ -3070,7 +3070,7 @@
               <a:tr h="400000">
                 <a:tc>
                   <a:txBody>
-                    <a:bodyPr/>
+                    <a:bodyPr wrap="square"/>
                     <a:lstStyle/>
                     <a:p>
                       <a:r>
@@ -3091,7 +3091,7 @@
                 </a:tc>
                 <a:tc>
                   <a:txBody>
-                    <a:bodyPr/>
+                    <a:bodyPr wrap="square"/>
                     <a:lstStyle/>
                     <a:p>
                       <a:r>
@@ -3112,7 +3112,7 @@
                 </a:tc>
                 <a:tc>
                   <a:txBody>
-                    <a:bodyPr/>
+                    <a:bodyPr wrap="square"/>
                     <a:lstStyle/>
                     <a:p>
                       <a:r>
@@ -3133,7 +3133,7 @@
                 </a:tc>
                 <a:tc>
                   <a:txBody>
-                    <a:bodyPr/>
+                    <a:bodyPr wrap="square"/>
                     <a:lstStyle/>
                     <a:p>
                       <a:r>
@@ -3156,7 +3156,7 @@
               <a:tr h="400000">
                 <a:tc>
                   <a:txBody>
-                    <a:bodyPr/>
+                    <a:bodyPr wrap="square"/>
                     <a:lstStyle/>
                     <a:p>
                       <a:r>
@@ -3173,7 +3173,7 @@
                 </a:tc>
                 <a:tc>
                   <a:txBody>
-                    <a:bodyPr/>
+                    <a:bodyPr wrap="square"/>
                     <a:lstStyle/>
                     <a:p>
                       <a:r>
@@ -3190,7 +3190,7 @@
                 </a:tc>
                 <a:tc>
                   <a:txBody>
-                    <a:bodyPr/>
+                    <a:bodyPr wrap="square"/>
                     <a:lstStyle/>
                     <a:p>
                       <a:r>
@@ -3207,7 +3207,7 @@
                 </a:tc>
                 <a:tc>
                   <a:txBody>
-                    <a:bodyPr/>
+                    <a:bodyPr wrap="square"/>
                     <a:lstStyle/>
                     <a:p>
                       <a:r>
@@ -3226,7 +3226,7 @@
               <a:tr h="400000">
                 <a:tc>
                   <a:txBody>
-                    <a:bodyPr/>
+                    <a:bodyPr wrap="square"/>
                     <a:lstStyle/>
                     <a:p>
                       <a:r>
@@ -3243,7 +3243,7 @@
                 </a:tc>
                 <a:tc>
                   <a:txBody>
-                    <a:bodyPr/>
+                    <a:bodyPr wrap="square"/>
                     <a:lstStyle/>
                     <a:p>
                       <a:r>
@@ -3260,7 +3260,7 @@
                 </a:tc>
                 <a:tc>
                   <a:txBody>
-                    <a:bodyPr/>
+                    <a:bodyPr wrap="square"/>
                     <a:lstStyle/>
                     <a:p>
                       <a:r>
@@ -3277,7 +3277,7 @@
                 </a:tc>
                 <a:tc>
                   <a:txBody>
-                    <a:bodyPr/>
+                    <a:bodyPr wrap="square"/>
                     <a:lstStyle/>
                     <a:p>
                       <a:r>
@@ -3296,7 +3296,7 @@
               <a:tr h="400000">
                 <a:tc>
                   <a:txBody>
-                    <a:bodyPr/>
+                    <a:bodyPr wrap="square"/>
                     <a:lstStyle/>
                     <a:p>
                       <a:r>
@@ -3313,7 +3313,7 @@
                 </a:tc>
                 <a:tc>
                   <a:txBody>
-                    <a:bodyPr/>
+                    <a:bodyPr wrap="square"/>
                     <a:lstStyle/>
                     <a:p>
                       <a:r>
@@ -3330,7 +3330,7 @@
                 </a:tc>
                 <a:tc>
                   <a:txBody>
-                    <a:bodyPr/>
+                    <a:bodyPr wrap="square"/>
                     <a:lstStyle/>
                     <a:p>
                       <a:r>
@@ -3347,7 +3347,7 @@
                 </a:tc>
                 <a:tc>
                   <a:txBody>
-                    <a:bodyPr/>
+                    <a:bodyPr wrap="square"/>
                     <a:lstStyle/>
                     <a:p>
                       <a:r>
@@ -3366,7 +3366,7 @@
               <a:tr h="400000">
                 <a:tc>
                   <a:txBody>
-                    <a:bodyPr/>
+                    <a:bodyPr wrap="square"/>
                     <a:lstStyle/>
                     <a:p>
                       <a:r>
@@ -3383,7 +3383,7 @@
                 </a:tc>
                 <a:tc>
                   <a:txBody>
-                    <a:bodyPr/>
+                    <a:bodyPr wrap="square"/>
                     <a:lstStyle/>
                     <a:p>
                       <a:r>
@@ -3400,7 +3400,7 @@
                 </a:tc>
                 <a:tc>
                   <a:txBody>
-                    <a:bodyPr/>
+                    <a:bodyPr wrap="square"/>
                     <a:lstStyle/>
                     <a:p>
                       <a:r>
@@ -3417,7 +3417,7 @@
                 </a:tc>
                 <a:tc>
                   <a:txBody>
-                    <a:bodyPr/>
+                    <a:bodyPr wrap="square"/>
                     <a:lstStyle/>
                     <a:p>
                       <a:r>
@@ -3436,7 +3436,7 @@
               <a:tr h="400000">
                 <a:tc>
                   <a:txBody>
-                    <a:bodyPr/>
+                    <a:bodyPr wrap="square"/>
                     <a:lstStyle/>
                     <a:p>
                       <a:r>
@@ -3457,7 +3457,7 @@
                 </a:tc>
                 <a:tc>
                   <a:txBody>
-                    <a:bodyPr/>
+                    <a:bodyPr wrap="square"/>
                     <a:lstStyle/>
                     <a:p>
                       <a:r>
@@ -3478,7 +3478,7 @@
                 </a:tc>
                 <a:tc>
                   <a:txBody>
-                    <a:bodyPr/>
+                    <a:bodyPr wrap="square"/>
                     <a:lstStyle/>
                     <a:p>
                       <a:r>
@@ -3499,7 +3499,7 @@
                 </a:tc>
                 <a:tc>
                   <a:txBody>
-                    <a:bodyPr/>
+                    <a:bodyPr wrap="square"/>
                     <a:lstStyle/>
                     <a:p>
                       <a:r>
@@ -5043,7 +5043,7 @@
               <a:tr h="400000">
                 <a:tc>
                   <a:txBody>
-                    <a:bodyPr/>
+                    <a:bodyPr wrap="square"/>
                     <a:lstStyle/>
                     <a:p>
                       <a:r>
@@ -5064,7 +5064,7 @@
                 </a:tc>
                 <a:tc>
                   <a:txBody>
-                    <a:bodyPr/>
+                    <a:bodyPr wrap="square"/>
                     <a:lstStyle/>
                     <a:p>
                       <a:r>
@@ -5085,7 +5085,7 @@
                 </a:tc>
                 <a:tc>
                   <a:txBody>
-                    <a:bodyPr/>
+                    <a:bodyPr wrap="square"/>
                     <a:lstStyle/>
                     <a:p>
                       <a:r>
@@ -5106,7 +5106,7 @@
                 </a:tc>
                 <a:tc>
                   <a:txBody>
-                    <a:bodyPr/>
+                    <a:bodyPr wrap="square"/>
                     <a:lstStyle/>
                     <a:p>
                       <a:r>
@@ -5127,7 +5127,7 @@
                 </a:tc>
                 <a:tc>
                   <a:txBody>
-                    <a:bodyPr/>
+                    <a:bodyPr wrap="square"/>
                     <a:lstStyle/>
                     <a:p>
                       <a:r>
@@ -5150,7 +5150,7 @@
               <a:tr h="400000">
                 <a:tc>
                   <a:txBody>
-                    <a:bodyPr/>
+                    <a:bodyPr wrap="square"/>
                     <a:lstStyle/>
                     <a:p>
                       <a:r>
@@ -5172,7 +5172,7 @@
                 </a:tc>
                 <a:tc>
                   <a:txBody>
-                    <a:bodyPr/>
+                    <a:bodyPr wrap="square"/>
                     <a:lstStyle/>
                     <a:p>
                       <a:r>
@@ -5194,7 +5194,7 @@
                 </a:tc>
                 <a:tc>
                   <a:txBody>
-                    <a:bodyPr/>
+                    <a:bodyPr wrap="square"/>
                     <a:lstStyle/>
                     <a:p>
                       <a:r>
@@ -5216,7 +5216,7 @@
                 </a:tc>
                 <a:tc>
                   <a:txBody>
-                    <a:bodyPr/>
+                    <a:bodyPr wrap="square"/>
                     <a:lstStyle/>
                     <a:p>
                       <a:r>
@@ -5238,7 +5238,7 @@
                 </a:tc>
                 <a:tc>
                   <a:txBody>
-                    <a:bodyPr/>
+                    <a:bodyPr wrap="square"/>
                     <a:lstStyle/>
                     <a:p>
                       <a:r>
@@ -5262,7 +5262,7 @@
               <a:tr h="400000">
                 <a:tc>
                   <a:txBody>
-                    <a:bodyPr/>
+                    <a:bodyPr wrap="square"/>
                     <a:lstStyle/>
                     <a:p>
                       <a:r>
@@ -5279,7 +5279,7 @@
                 </a:tc>
                 <a:tc>
                   <a:txBody>
-                    <a:bodyPr/>
+                    <a:bodyPr wrap="square"/>
                     <a:lstStyle/>
                     <a:p>
                       <a:r>
@@ -5296,7 +5296,7 @@
                 </a:tc>
                 <a:tc>
                   <a:txBody>
-                    <a:bodyPr/>
+                    <a:bodyPr wrap="square"/>
                     <a:lstStyle/>
                     <a:p>
                       <a:r>
@@ -5313,7 +5313,7 @@
                 </a:tc>
                 <a:tc>
                   <a:txBody>
-                    <a:bodyPr/>
+                    <a:bodyPr wrap="square"/>
                     <a:lstStyle/>
                     <a:p>
                       <a:r>
@@ -5330,7 +5330,7 @@
                 </a:tc>
                 <a:tc>
                   <a:txBody>
-                    <a:bodyPr/>
+                    <a:bodyPr wrap="square"/>
                     <a:lstStyle/>
                     <a:p>
                       <a:r>
@@ -8058,7 +8058,7 @@
               <a:tr h="400000">
                 <a:tc>
                   <a:txBody>
-                    <a:bodyPr/>
+                    <a:bodyPr wrap="square"/>
                     <a:lstStyle/>
                     <a:p>
                       <a:r>
@@ -8079,7 +8079,7 @@
                 </a:tc>
                 <a:tc>
                   <a:txBody>
-                    <a:bodyPr/>
+                    <a:bodyPr wrap="square"/>
                     <a:lstStyle/>
                     <a:p>
                       <a:r>
@@ -8100,7 +8100,7 @@
                 </a:tc>
                 <a:tc>
                   <a:txBody>
-                    <a:bodyPr/>
+                    <a:bodyPr wrap="square"/>
                     <a:lstStyle/>
                     <a:p>
                       <a:r>
@@ -8121,7 +8121,7 @@
                 </a:tc>
                 <a:tc>
                   <a:txBody>
-                    <a:bodyPr/>
+                    <a:bodyPr wrap="square"/>
                     <a:lstStyle/>
                     <a:p>
                       <a:r>
@@ -8144,7 +8144,7 @@
               <a:tr h="400000">
                 <a:tc>
                   <a:txBody>
-                    <a:bodyPr/>
+                    <a:bodyPr wrap="square"/>
                     <a:lstStyle/>
                     <a:p>
                       <a:r>
@@ -8161,7 +8161,7 @@
                 </a:tc>
                 <a:tc>
                   <a:txBody>
-                    <a:bodyPr/>
+                    <a:bodyPr wrap="square"/>
                     <a:lstStyle/>
                     <a:p>
                       <a:r>
@@ -8174,7 +8174,7 @@
                 </a:tc>
                 <a:tc>
                   <a:txBody>
-                    <a:bodyPr/>
+                    <a:bodyPr wrap="square"/>
                     <a:lstStyle/>
                     <a:p>
                       <a:r>
@@ -8191,7 +8191,7 @@
                 </a:tc>
                 <a:tc>
                   <a:txBody>
-                    <a:bodyPr/>
+                    <a:bodyPr wrap="square"/>
                     <a:lstStyle/>
                     <a:p>
                       <a:r>
@@ -8206,7 +8206,7 @@
               <a:tr h="400000">
                 <a:tc>
                   <a:txBody>
-                    <a:bodyPr/>
+                    <a:bodyPr wrap="square"/>
                     <a:lstStyle/>
                     <a:p>
                       <a:r>
@@ -8223,7 +8223,7 @@
                 </a:tc>
                 <a:tc>
                   <a:txBody>
-                    <a:bodyPr/>
+                    <a:bodyPr wrap="square"/>
                     <a:lstStyle/>
                     <a:p>
                       <a:r>
@@ -8236,7 +8236,7 @@
                 </a:tc>
                 <a:tc>
                   <a:txBody>
-                    <a:bodyPr/>
+                    <a:bodyPr wrap="square"/>
                     <a:lstStyle/>
                     <a:p>
                       <a:r>
@@ -8253,7 +8253,7 @@
                 </a:tc>
                 <a:tc>
                   <a:txBody>
-                    <a:bodyPr/>
+                    <a:bodyPr wrap="square"/>
                     <a:lstStyle/>
                     <a:p>
                       <a:r>
@@ -8268,7 +8268,7 @@
               <a:tr h="400000">
                 <a:tc>
                   <a:txBody>
-                    <a:bodyPr/>
+                    <a:bodyPr wrap="square"/>
                     <a:lstStyle/>
                     <a:p>
                       <a:r>
@@ -8285,7 +8285,7 @@
                 </a:tc>
                 <a:tc>
                   <a:txBody>
-                    <a:bodyPr/>
+                    <a:bodyPr wrap="square"/>
                     <a:lstStyle/>
                     <a:p>
                       <a:r>
@@ -8298,7 +8298,7 @@
                 </a:tc>
                 <a:tc>
                   <a:txBody>
-                    <a:bodyPr/>
+                    <a:bodyPr wrap="square"/>
                     <a:lstStyle/>
                     <a:p>
                       <a:r>
@@ -8311,7 +8311,7 @@
                 </a:tc>
                 <a:tc>
                   <a:txBody>
-                    <a:bodyPr/>
+                    <a:bodyPr wrap="square"/>
                     <a:lstStyle/>
                     <a:p>
                       <a:r>
@@ -8330,7 +8330,7 @@
               <a:tr h="400000">
                 <a:tc>
                   <a:txBody>
-                    <a:bodyPr/>
+                    <a:bodyPr wrap="square"/>
                     <a:lstStyle/>
                     <a:p>
                       <a:r>
@@ -8347,7 +8347,7 @@
                 </a:tc>
                 <a:tc>
                   <a:txBody>
-                    <a:bodyPr/>
+                    <a:bodyPr wrap="square"/>
                     <a:lstStyle/>
                     <a:p>
                       <a:r>
@@ -8360,7 +8360,7 @@
                 </a:tc>
                 <a:tc>
                   <a:txBody>
-                    <a:bodyPr/>
+                    <a:bodyPr wrap="square"/>
                     <a:lstStyle/>
                     <a:p>
                       <a:r>
@@ -8373,7 +8373,7 @@
                 </a:tc>
                 <a:tc>
                   <a:txBody>
-                    <a:bodyPr/>
+                    <a:bodyPr wrap="square"/>
                     <a:lstStyle/>
                     <a:p>
                       <a:r>
@@ -8388,7 +8388,7 @@
               <a:tr h="400000">
                 <a:tc>
                   <a:txBody>
-                    <a:bodyPr/>
+                    <a:bodyPr wrap="square"/>
                     <a:lstStyle/>
                     <a:p>
                       <a:r>
@@ -8405,7 +8405,7 @@
                 </a:tc>
                 <a:tc>
                   <a:txBody>
-                    <a:bodyPr/>
+                    <a:bodyPr wrap="square"/>
                     <a:lstStyle/>
                     <a:p>
                       <a:r>
@@ -8418,7 +8418,7 @@
                 </a:tc>
                 <a:tc>
                   <a:txBody>
-                    <a:bodyPr/>
+                    <a:bodyPr wrap="square"/>
                     <a:lstStyle/>
                     <a:p>
                       <a:r>
@@ -8431,7 +8431,7 @@
                 </a:tc>
                 <a:tc>
                   <a:txBody>
-                    <a:bodyPr/>
+                    <a:bodyPr wrap="square"/>
                     <a:lstStyle/>
                     <a:p>
                       <a:r>
@@ -8446,7 +8446,7 @@
               <a:tr h="400000">
                 <a:tc>
                   <a:txBody>
-                    <a:bodyPr/>
+                    <a:bodyPr wrap="square"/>
                     <a:lstStyle/>
                     <a:p>
                       <a:r>
@@ -8463,7 +8463,7 @@
                 </a:tc>
                 <a:tc>
                   <a:txBody>
-                    <a:bodyPr/>
+                    <a:bodyPr wrap="square"/>
                     <a:lstStyle/>
                     <a:p>
                       <a:r>
@@ -8480,7 +8480,7 @@
                 </a:tc>
                 <a:tc>
                   <a:txBody>
-                    <a:bodyPr/>
+                    <a:bodyPr wrap="square"/>
                     <a:lstStyle/>
                     <a:p>
                       <a:r>
@@ -8497,7 +8497,7 @@
                 </a:tc>
                 <a:tc>
                   <a:txBody>
-                    <a:bodyPr/>
+                    <a:bodyPr wrap="square"/>
                     <a:lstStyle/>
                     <a:p>
                       <a:r>
@@ -8708,7 +8708,7 @@
               <a:tr h="400000">
                 <a:tc>
                   <a:txBody>
-                    <a:bodyPr/>
+                    <a:bodyPr wrap="square"/>
                     <a:lstStyle/>
                     <a:p>
                       <a:r>
@@ -8729,7 +8729,7 @@
                 </a:tc>
                 <a:tc>
                   <a:txBody>
-                    <a:bodyPr/>
+                    <a:bodyPr wrap="square"/>
                     <a:lstStyle/>
                     <a:p>
                       <a:r>
@@ -8748,7 +8748,7 @@
               <a:tr h="400000">
                 <a:tc>
                   <a:txBody>
-                    <a:bodyPr/>
+                    <a:bodyPr wrap="square"/>
                     <a:lstStyle/>
                     <a:p>
                       <a:r>
@@ -8765,7 +8765,7 @@
                 </a:tc>
                 <a:tc>
                   <a:txBody>
-                    <a:bodyPr/>
+                    <a:bodyPr wrap="square"/>
                     <a:lstStyle/>
                     <a:p>
                       <a:r>
@@ -8780,7 +8780,7 @@
               <a:tr h="400000">
                 <a:tc>
                   <a:txBody>
-                    <a:bodyPr/>
+                    <a:bodyPr wrap="square"/>
                     <a:lstStyle/>
                     <a:p>
                       <a:r>
@@ -8797,7 +8797,7 @@
                 </a:tc>
                 <a:tc>
                   <a:txBody>
-                    <a:bodyPr/>
+                    <a:bodyPr wrap="square"/>
                     <a:lstStyle/>
                     <a:p>
                       <a:r>
@@ -8812,7 +8812,7 @@
               <a:tr h="400000">
                 <a:tc>
                   <a:txBody>
-                    <a:bodyPr/>
+                    <a:bodyPr wrap="square"/>
                     <a:lstStyle/>
                     <a:p>
                       <a:r>
@@ -8829,7 +8829,7 @@
                 </a:tc>
                 <a:tc>
                   <a:txBody>
-                    <a:bodyPr/>
+                    <a:bodyPr wrap="square"/>
                     <a:lstStyle/>
                     <a:p>
                       <a:r>
@@ -8844,7 +8844,7 @@
               <a:tr h="400000">
                 <a:tc>
                   <a:txBody>
-                    <a:bodyPr/>
+                    <a:bodyPr wrap="square"/>
                     <a:lstStyle/>
                     <a:p>
                       <a:r>
@@ -8861,7 +8861,7 @@
                 </a:tc>
                 <a:tc>
                   <a:txBody>
-                    <a:bodyPr/>
+                    <a:bodyPr wrap="square"/>
                     <a:lstStyle/>
                     <a:p>
                       <a:r>
@@ -8876,7 +8876,7 @@
               <a:tr h="400000">
                 <a:tc>
                   <a:txBody>
-                    <a:bodyPr/>
+                    <a:bodyPr wrap="square"/>
                     <a:lstStyle/>
                     <a:p>
                       <a:r>
@@ -8893,7 +8893,7 @@
                 </a:tc>
                 <a:tc>
                   <a:txBody>
-                    <a:bodyPr/>
+                    <a:bodyPr wrap="square"/>
                     <a:lstStyle/>
                     <a:p>
                       <a:r>
@@ -8908,7 +8908,7 @@
               <a:tr h="400000">
                 <a:tc>
                   <a:txBody>
-                    <a:bodyPr/>
+                    <a:bodyPr wrap="square"/>
                     <a:lstStyle/>
                     <a:p>
                       <a:r>
@@ -8925,7 +8925,7 @@
                 </a:tc>
                 <a:tc>
                   <a:txBody>
-                    <a:bodyPr/>
+                    <a:bodyPr wrap="square"/>
                     <a:lstStyle/>
                     <a:p>
                       <a:r>
@@ -9326,7 +9326,7 @@
               <a:tr h="400000">
                 <a:tc gridSpan="4">
                   <a:txBody>
-                    <a:bodyPr/>
+                    <a:bodyPr wrap="square"/>
                     <a:lstStyle/>
                     <a:p>
                       <a:r>
@@ -9373,7 +9373,7 @@
               <a:tr h="400000">
                 <a:tc rowSpan="2">
                   <a:txBody>
-                    <a:bodyPr/>
+                    <a:bodyPr wrap="square"/>
                     <a:lstStyle/>
                     <a:p>
                       <a:r>
@@ -9394,7 +9394,7 @@
                 </a:tc>
                 <a:tc>
                   <a:txBody>
-                    <a:bodyPr/>
+                    <a:bodyPr wrap="square"/>
                     <a:lstStyle/>
                     <a:p>
                       <a:r>
@@ -9411,9 +9411,9 @@
                 </a:tc>
                 <a:tc>
                   <a:txBody>
-                    <a:bodyPr/>
-                    <a:lstStyle/>
-                    <a:p>
+                    <a:bodyPr wrap="square"/>
+                    <a:lstStyle/>
+                    <a:p algn="r">
                       <a:r>
                         <a:rPr lang="en-US" dirty="0">
                           <a:solidFill>
@@ -9428,9 +9428,9 @@
                 </a:tc>
                 <a:tc>
                   <a:txBody>
-                    <a:bodyPr/>
-                    <a:lstStyle/>
-                    <a:p>
+                    <a:bodyPr wrap="square"/>
+                    <a:lstStyle/>
+                    <a:p algn="r">
                       <a:r>
                         <a:rPr lang="en-US" dirty="0" b="1">
                           <a:solidFill>
@@ -9455,7 +9455,7 @@
                 </a:tc>
                 <a:tc>
                   <a:txBody>
-                    <a:bodyPr/>
+                    <a:bodyPr wrap="square"/>
                     <a:lstStyle/>
                     <a:p>
                       <a:r>
@@ -9472,9 +9472,9 @@
                 </a:tc>
                 <a:tc>
                   <a:txBody>
-                    <a:bodyPr/>
-                    <a:lstStyle/>
-                    <a:p>
+                    <a:bodyPr wrap="square"/>
+                    <a:lstStyle/>
+                    <a:p algn="r">
                       <a:r>
                         <a:rPr lang="en-US" dirty="0">
                           <a:solidFill>
@@ -9489,9 +9489,9 @@
                 </a:tc>
                 <a:tc>
                   <a:txBody>
-                    <a:bodyPr/>
-                    <a:lstStyle/>
-                    <a:p>
+                    <a:bodyPr wrap="square"/>
+                    <a:lstStyle/>
+                    <a:p algn="r">
                       <a:r>
                         <a:rPr lang="en-US" dirty="0" b="1">
                           <a:solidFill>
@@ -9508,7 +9508,7 @@
               <a:tr h="400000">
                 <a:tc rowSpan="2">
                   <a:txBody>
-                    <a:bodyPr/>
+                    <a:bodyPr wrap="square"/>
                     <a:lstStyle/>
                     <a:p>
                       <a:r>
@@ -9529,7 +9529,7 @@
                 </a:tc>
                 <a:tc>
                   <a:txBody>
-                    <a:bodyPr/>
+                    <a:bodyPr wrap="square"/>
                     <a:lstStyle/>
                     <a:p>
                       <a:r>
@@ -9546,9 +9546,9 @@
                 </a:tc>
                 <a:tc>
                   <a:txBody>
-                    <a:bodyPr/>
-                    <a:lstStyle/>
-                    <a:p>
+                    <a:bodyPr wrap="square"/>
+                    <a:lstStyle/>
+                    <a:p algn="r">
                       <a:r>
                         <a:rPr lang="en-US" dirty="0">
                           <a:solidFill>
@@ -9563,9 +9563,9 @@
                 </a:tc>
                 <a:tc>
                   <a:txBody>
-                    <a:bodyPr/>
-                    <a:lstStyle/>
-                    <a:p>
+                    <a:bodyPr wrap="square"/>
+                    <a:lstStyle/>
+                    <a:p algn="r">
                       <a:r>
                         <a:rPr lang="en-US" dirty="0" b="1">
                           <a:solidFill>
@@ -9590,7 +9590,7 @@
                 </a:tc>
                 <a:tc>
                   <a:txBody>
-                    <a:bodyPr/>
+                    <a:bodyPr wrap="square"/>
                     <a:lstStyle/>
                     <a:p>
                       <a:r>
@@ -9607,9 +9607,9 @@
                 </a:tc>
                 <a:tc>
                   <a:txBody>
-                    <a:bodyPr/>
-                    <a:lstStyle/>
-                    <a:p>
+                    <a:bodyPr wrap="square"/>
+                    <a:lstStyle/>
+                    <a:p algn="r">
                       <a:r>
                         <a:rPr lang="en-US" dirty="0">
                           <a:solidFill>
@@ -9624,9 +9624,9 @@
                 </a:tc>
                 <a:tc>
                   <a:txBody>
-                    <a:bodyPr/>
-                    <a:lstStyle/>
-                    <a:p>
+                    <a:bodyPr wrap="square"/>
+                    <a:lstStyle/>
+                    <a:p algn="r">
                       <a:r>
                         <a:rPr lang="en-US" dirty="0" b="1">
                           <a:solidFill>
@@ -10060,7 +10060,7 @@
               <a:tr h="400000">
                 <a:tc>
                   <a:txBody>
-                    <a:bodyPr/>
+                    <a:bodyPr wrap="square"/>
                     <a:lstStyle/>
                     <a:p>
                       <a:r>
@@ -10077,7 +10077,7 @@
                 </a:tc>
                 <a:tc>
                   <a:txBody>
-                    <a:bodyPr/>
+                    <a:bodyPr wrap="square"/>
                     <a:lstStyle/>
                     <a:p>
                       <a:r>
@@ -10094,7 +10094,7 @@
                 </a:tc>
                 <a:tc>
                   <a:txBody>
-                    <a:bodyPr/>
+                    <a:bodyPr wrap="square"/>
                     <a:lstStyle/>
                     <a:p>
                       <a:r>
@@ -10113,7 +10113,7 @@
               <a:tr h="400000">
                 <a:tc>
                   <a:txBody>
-                    <a:bodyPr/>
+                    <a:bodyPr wrap="square"/>
                     <a:lstStyle/>
                     <a:p>
                       <a:r>
@@ -10126,7 +10126,7 @@
                 </a:tc>
                 <a:tc>
                   <a:txBody>
-                    <a:bodyPr/>
+                    <a:bodyPr wrap="square"/>
                     <a:lstStyle/>
                     <a:p>
                       <a:r>
@@ -10139,7 +10139,7 @@
                 </a:tc>
                 <a:tc>
                   <a:txBody>
-                    <a:bodyPr/>
+                    <a:bodyPr wrap="square"/>
                     <a:lstStyle/>
                     <a:p>
                       <a:r>
@@ -10158,7 +10158,7 @@
               <a:tr h="400000">
                 <a:tc>
                   <a:txBody>
-                    <a:bodyPr/>
+                    <a:bodyPr wrap="square"/>
                     <a:lstStyle/>
                     <a:p>
                       <a:r>
@@ -10175,7 +10175,7 @@
                 </a:tc>
                 <a:tc>
                   <a:txBody>
-                    <a:bodyPr/>
+                    <a:bodyPr wrap="square"/>
                     <a:lstStyle/>
                     <a:p>
                       <a:r>
@@ -10192,7 +10192,7 @@
                 </a:tc>
                 <a:tc>
                   <a:txBody>
-                    <a:bodyPr/>
+                    <a:bodyPr wrap="square"/>
                     <a:lstStyle/>
                     <a:p>
                       <a:r>
@@ -10211,7 +10211,7 @@
               <a:tr h="400000">
                 <a:tc>
                   <a:txBody>
-                    <a:bodyPr/>
+                    <a:bodyPr wrap="square"/>
                     <a:lstStyle/>
                     <a:p>
                       <a:r>
@@ -10224,7 +10224,7 @@
                 </a:tc>
                 <a:tc>
                   <a:txBody>
-                    <a:bodyPr/>
+                    <a:bodyPr wrap="square"/>
                     <a:lstStyle/>
                     <a:p>
                       <a:r>
@@ -10237,7 +10237,7 @@
                 </a:tc>
                 <a:tc>
                   <a:txBody>
-                    <a:bodyPr/>
+                    <a:bodyPr wrap="square"/>
                     <a:lstStyle/>
                     <a:p>
                       <a:r>
@@ -10620,12 +10620,12 @@
 <file path=ppt/theme/theme1.xml><?xml version="1.0" encoding="utf-8"?>
 <a:theme xmlns:a="http://schemas.openxmlformats.org/drawingml/2006/main" name="Office Theme">
   <a:themeElements>
-    <a:clrScheme name="Office">
+    <a:clrScheme name="Office Theme">
       <a:dk1>
-        <a:sysClr val="windowText" lastClr="000000"/>
+        <a:srgbClr val="000000"/>
       </a:dk1>
       <a:lt1>
-        <a:sysClr val="window" lastClr="FFFFFF"/>
+        <a:srgbClr val="FFFFFF"/>
       </a:lt1>
       <a:dk2>
         <a:srgbClr val="1F497D"/>
@@ -10660,7 +10660,7 @@
     </a:clrScheme>
     <a:fontScheme name="Office">
       <a:majorFont>
-        <a:latin typeface="Calibri"/>
+        <a:latin typeface="Calibri Light"/>
         <a:ea typeface=""/>
         <a:cs typeface=""/>
       </a:majorFont>

</xml_diff>